<commit_message>
• Implement command processing and CAN temperature notifications
  - Process write commands through an ordered workqueue with completion.
  - Handle temp, limits, start, and stop commands.
  - Initialize a CAN_RAW socket and release it after draining the workqueue.
  - Send frame 0x124 on temperature status transitions while running.
  - Preserve local temperature monitoring while stopped.
  - Update documentation and presentation.

 Verified build, overheat and recovery notifications, suppression of
 duplicate notifications, stopped behavior, and module unload.
</commit_message>
<xml_diff>
--- a/docs/presentation/virtual_board.pptx
+++ b/docs/presentation/virtual_board.pptx
@@ -583,7 +583,7 @@
                 </a:solidFill>
                 <a:latin typeface="DejaVu Sans"/>
               </a:rPr>
-              <a:t>Рабочая версия · 18.09.2026 · промежуточная презентация</a:t>
+              <a:t>Рабочая версия · 21.09.2026 · промежуточная презентация</a:t>
             </a:r>
             <a:endParaRPr b="0" lang="en-US" sz="1400" spc="-1" strike="noStrike">
               <a:solidFill>
@@ -827,7 +827,7 @@
                 </a:solidFill>
                 <a:latin typeface="DejaVu Sans"/>
               </a:rPr>
-              <a:t>Сейчас: минимальный модуль собран, загружен и выгружен.</a:t>
+              <a:t>Проверено: write → workqueue → CAN → candump.</a:t>
             </a:r>
             <a:endParaRPr b="0" lang="en-US" sz="1500" spc="-1" strike="noStrike">
               <a:solidFill>
@@ -990,7 +990,7 @@
                 </a:solidFill>
                 <a:latin typeface="DejaVu Sans"/>
               </a:rPr>
-              <a:t>Рабочая версия · 18.09.2026 · согласованный объём</a:t>
+              <a:t>Рабочая версия · 21.09.2026 · согласованный объём</a:t>
             </a:r>
             <a:endParaRPr b="0" lang="en-US" sz="1400" spc="-1" strike="noStrike">
               <a:solidFill>
@@ -1469,7 +1469,7 @@
                 </a:solidFill>
                 <a:latin typeface="DejaVu Sans"/>
               </a:rPr>
-              <a:t>Рабочая версия · 18.09.2026 · проектная схема; CAN-часть ещё не реализована</a:t>
+              <a:t>Рабочая версия · 21.09.2026 · первый CAN-кадр проверен</a:t>
             </a:r>
             <a:endParaRPr b="0" lang="en-US" sz="1400" spc="-1" strike="noStrike">
               <a:solidFill>
@@ -1879,7 +1879,7 @@
                 </a:solidFill>
                 <a:latin typeface="DejaVu Sans"/>
               </a:rPr>
-              <a:t>Модуль создаст и привяжет собственный CAN-сокет.</a:t>
+              <a:t>Кадры 0x124 получены в candump.</a:t>
             </a:r>
             <a:endParaRPr b="0" lang="en-US" sz="2100" spc="-1" strike="noStrike">
               <a:solidFill>
@@ -2101,7 +2101,7 @@
                 </a:solidFill>
                 <a:latin typeface="DejaVu Sans"/>
               </a:rPr>
-              <a:t>Рабочая версия · 18.09.2026 · архитектура; реализация впереди</a:t>
+              <a:t>Рабочая версия · 21.09.2026 · архитектура; реализация впереди</a:t>
             </a:r>
             <a:endParaRPr b="0" lang="en-US" sz="1400" spc="-1" strike="noStrike">
               <a:solidFill>
@@ -2812,7 +2812,7 @@
                 </a:solidFill>
                 <a:latin typeface="DejaVu Sans"/>
               </a:rPr>
-              <a:t>Рабочая версия · 18.09.2026 · согласованное поведение; реализация впереди</a:t>
+              <a:t>Рабочая версия · 21.09.2026 · CAN-переходы проверены; FIFO впереди</a:t>
             </a:r>
             <a:endParaRPr b="0" lang="en-US" sz="1400" spc="-1" strike="noStrike">
               <a:solidFill>
@@ -3249,7 +3249,7 @@
                 </a:solidFill>
                 <a:latin typeface="DejaVu Sans"/>
               </a:rPr>
-              <a:t>Механизмы из материалов курса</a:t>
+              <a:t>Как выполняется команда</a:t>
             </a:r>
             <a:endParaRPr b="0" lang="en-US" sz="3000" spc="-1" strike="noStrike">
               <a:solidFill>
@@ -3291,7 +3291,7 @@
                 </a:solidFill>
                 <a:latin typeface="DejaVu Sans"/>
               </a:rPr>
-              <a:t>Рабочая версия · 18.09.2026 · выбранная архитектура</a:t>
+              <a:t>Рабочая версия · 21.09.2026 · write реализован и испытан</a:t>
             </a:r>
             <a:endParaRPr b="0" lang="en-US" sz="1400" spc="-1" strike="noStrike">
               <a:solidFill>
@@ -3377,92 +3377,92 @@
                 </a:solidFill>
                 <a:latin typeface="DejaVu Sans"/>
               </a:rPr>
-              <a:t>Лекции и ДЗ</a:t>
-            </a:r>
-            <a:endParaRPr b="0" lang="en-US" sz="2100" spc="-1" strike="noStrike">
-              <a:solidFill>
-                <a:srgbClr val="ffffff"/>
-              </a:solidFill>
-              <a:latin typeface="Arial"/>
-            </a:endParaRPr>
-          </a:p>
-          <a:p>
-            <a:r>
-              <a:rPr b="0" lang="en-US" sz="2100" spc="-1" strike="noStrike">
-                <a:solidFill>
-                  <a:srgbClr val="e5edf6"/>
-                </a:solidFill>
-                <a:latin typeface="DejaVu Sans"/>
-              </a:rPr>
-              <a:t>ДЗ22: таймер и workqueue</a:t>
-            </a:r>
-            <a:endParaRPr b="0" lang="en-US" sz="2100" spc="-1" strike="noStrike">
-              <a:solidFill>
-                <a:srgbClr val="ffffff"/>
-              </a:solidFill>
-              <a:latin typeface="Arial"/>
-            </a:endParaRPr>
-          </a:p>
-          <a:p>
-            <a:r>
-              <a:rPr b="0" lang="en-US" sz="2100" spc="-1" strike="noStrike">
-                <a:solidFill>
-                  <a:srgbClr val="e5edf6"/>
-                </a:solidFill>
-                <a:latin typeface="DejaVu Sans"/>
-              </a:rPr>
-              <a:t>ДЗ14: сокеты ядра</a:t>
-            </a:r>
-            <a:endParaRPr b="0" lang="en-US" sz="2100" spc="-1" strike="noStrike">
-              <a:solidFill>
-                <a:srgbClr val="ffffff"/>
-              </a:solidFill>
-              <a:latin typeface="Arial"/>
-            </a:endParaRPr>
-          </a:p>
-          <a:p>
-            <a:r>
-              <a:rPr b="0" lang="en-US" sz="2100" spc="-1" strike="noStrike">
-                <a:solidFill>
-                  <a:srgbClr val="e5edf6"/>
-                </a:solidFill>
-                <a:latin typeface="DejaVu Sans"/>
-              </a:rPr>
-              <a:t>ДЗ11: kfifo</a:t>
-            </a:r>
-            <a:endParaRPr b="0" lang="en-US" sz="2100" spc="-1" strike="noStrike">
-              <a:solidFill>
-                <a:srgbClr val="ffffff"/>
-              </a:solidFill>
-              <a:latin typeface="Arial"/>
-            </a:endParaRPr>
-          </a:p>
-          <a:p>
-            <a:r>
-              <a:rPr b="0" lang="en-US" sz="2100" spc="-1" strike="noStrike">
-                <a:solidFill>
-                  <a:srgbClr val="e5edf6"/>
-                </a:solidFill>
-                <a:latin typeface="DejaVu Sans"/>
-              </a:rPr>
-              <a:t>ДЗ10 / ДЗ18: списки и mutex</a:t>
-            </a:r>
-            <a:endParaRPr b="0" lang="en-US" sz="2100" spc="-1" strike="noStrike">
-              <a:solidFill>
-                <a:srgbClr val="ffffff"/>
-              </a:solidFill>
-              <a:latin typeface="Arial"/>
-            </a:endParaRPr>
-          </a:p>
-          <a:p>
-            <a:r>
-              <a:rPr b="0" lang="en-US" sz="2100" spc="-1" strike="noStrike">
-                <a:solidFill>
-                  <a:srgbClr val="e5edf6"/>
-                </a:solidFill>
-                <a:latin typeface="DejaVu Sans"/>
-              </a:rPr>
-              <a:t>Лекции 31 / 33: интерфейсы</a:t>
+              <a:t>Отправитель команды</a:t>
+            </a:r>
+            <a:endParaRPr b="0" lang="en-US" sz="2100" spc="-1" strike="noStrike">
+              <a:solidFill>
+                <a:srgbClr val="ffffff"/>
+              </a:solidFill>
+              <a:latin typeface="Arial"/>
+            </a:endParaRPr>
+          </a:p>
+          <a:p>
+            <a:r>
+              <a:rPr b="0" lang="en-US" sz="2100" spc="-1" strike="noStrike">
+                <a:solidFill>
+                  <a:srgbClr val="e5edf6"/>
+                </a:solidFill>
+                <a:latin typeface="DejaVu Sans"/>
+              </a:rPr>
+              <a:t>write: копирование и разбор</a:t>
+            </a:r>
+            <a:endParaRPr b="0" lang="en-US" sz="2100" spc="-1" strike="noStrike">
+              <a:solidFill>
+                <a:srgbClr val="ffffff"/>
+              </a:solidFill>
+              <a:latin typeface="Arial"/>
+            </a:endParaRPr>
+          </a:p>
+          <a:p>
+            <a:r>
+              <a:rPr b="0" lang="en-US" sz="2100" spc="-1" strike="noStrike">
+                <a:solidFill>
+                  <a:srgbClr val="e5edf6"/>
+                </a:solidFill>
+                <a:latin typeface="DejaVu Sans"/>
+              </a:rPr>
+              <a:t>command_lock: один отправитель</a:t>
+            </a:r>
+            <a:endParaRPr b="0" lang="en-US" sz="2100" spc="-1" strike="noStrike">
+              <a:solidFill>
+                <a:srgbClr val="ffffff"/>
+              </a:solidFill>
+              <a:latin typeface="Arial"/>
+            </a:endParaRPr>
+          </a:p>
+          <a:p>
+            <a:r>
+              <a:rPr b="0" lang="en-US" sz="2100" spc="-1" strike="noStrike">
+                <a:solidFill>
+                  <a:srgbClr val="e5edf6"/>
+                </a:solidFill>
+                <a:latin typeface="DejaVu Sans"/>
+              </a:rPr>
+              <a:t>Заявка: work + command + done</a:t>
+            </a:r>
+            <a:endParaRPr b="0" lang="en-US" sz="2100" spc="-1" strike="noStrike">
+              <a:solidFill>
+                <a:srgbClr val="ffffff"/>
+              </a:solidFill>
+              <a:latin typeface="Arial"/>
+            </a:endParaRPr>
+          </a:p>
+          <a:p>
+            <a:r>
+              <a:rPr b="0" lang="en-US" sz="2100" spc="-1" strike="noStrike">
+                <a:solidFill>
+                  <a:srgbClr val="e5edf6"/>
+                </a:solidFill>
+                <a:latin typeface="DejaVu Sans"/>
+              </a:rPr>
+              <a:t>queue_work → очередь ядра</a:t>
+            </a:r>
+            <a:endParaRPr b="0" lang="en-US" sz="2100" spc="-1" strike="noStrike">
+              <a:solidFill>
+                <a:srgbClr val="ffffff"/>
+              </a:solidFill>
+              <a:latin typeface="Arial"/>
+            </a:endParaRPr>
+          </a:p>
+          <a:p>
+            <a:r>
+              <a:rPr b="0" lang="en-US" sz="2100" spc="-1" strike="noStrike">
+                <a:solidFill>
+                  <a:srgbClr val="e5edf6"/>
+                </a:solidFill>
+                <a:latin typeface="DejaVu Sans"/>
+              </a:rPr>
+              <a:t>Ожидание → результат → kfree</a:t>
             </a:r>
             <a:endParaRPr b="0" lang="en-US" sz="2100" spc="-1" strike="noStrike">
               <a:solidFill>
@@ -3506,92 +3506,92 @@
                 </a:solidFill>
                 <a:latin typeface="DejaVu Sans"/>
               </a:rPr>
-              <a:t>Применение в проекте</a:t>
-            </a:r>
-            <a:endParaRPr b="0" lang="en-US" sz="2100" spc="-1" strike="noStrike">
-              <a:solidFill>
-                <a:srgbClr val="ffffff"/>
-              </a:solidFill>
-              <a:latin typeface="Arial"/>
-            </a:endParaRPr>
-          </a:p>
-          <a:p>
-            <a:r>
-              <a:rPr b="0" lang="en-US" sz="2100" spc="-1" strike="noStrike">
-                <a:solidFill>
-                  <a:srgbClr val="e5edf6"/>
-                </a:solidFill>
-                <a:latin typeface="DejaVu Sans"/>
-              </a:rPr>
-              <a:t>hrtimer назначает работу</a:t>
-            </a:r>
-            <a:endParaRPr b="0" lang="en-US" sz="2100" spc="-1" strike="noStrike">
-              <a:solidFill>
-                <a:srgbClr val="ffffff"/>
-              </a:solidFill>
-              <a:latin typeface="Arial"/>
-            </a:endParaRPr>
-          </a:p>
-          <a:p>
-            <a:r>
-              <a:rPr b="0" lang="en-US" sz="2100" spc="-1" strike="noStrike">
-                <a:solidFill>
-                  <a:srgbClr val="e5edf6"/>
-                </a:solidFill>
-                <a:latin typeface="DejaVu Sans"/>
-              </a:rPr>
-              <a:t>Worker отправляет CAN</a:t>
-            </a:r>
-            <a:endParaRPr b="0" lang="en-US" sz="2100" spc="-1" strike="noStrike">
-              <a:solidFill>
-                <a:srgbClr val="ffffff"/>
-              </a:solidFill>
-              <a:latin typeface="Arial"/>
-            </a:endParaRPr>
-          </a:p>
-          <a:p>
-            <a:r>
-              <a:rPr b="0" lang="en-US" sz="2100" spc="-1" strike="noStrike">
-                <a:solidFill>
-                  <a:srgbClr val="e5edf6"/>
-                </a:solidFill>
-                <a:latin typeface="DejaVu Sans"/>
-              </a:rPr>
-              <a:t>FIFO хранит события</a:t>
-            </a:r>
-            <a:endParaRPr b="0" lang="en-US" sz="2100" spc="-1" strike="noStrike">
-              <a:solidFill>
-                <a:srgbClr val="ffffff"/>
-              </a:solidFill>
-              <a:latin typeface="Arial"/>
-            </a:endParaRPr>
-          </a:p>
-          <a:p>
-            <a:r>
-              <a:rPr b="0" lang="en-US" sz="2100" spc="-1" strike="noStrike">
-                <a:solidFill>
-                  <a:srgbClr val="e5edf6"/>
-                </a:solidFill>
-                <a:latin typeface="DejaVu Sans"/>
-              </a:rPr>
-              <a:t>Блокировки защищают данные</a:t>
-            </a:r>
-            <a:endParaRPr b="0" lang="en-US" sz="2100" spc="-1" strike="noStrike">
-              <a:solidFill>
-                <a:srgbClr val="ffffff"/>
-              </a:solidFill>
-              <a:latin typeface="Arial"/>
-            </a:endParaRPr>
-          </a:p>
-          <a:p>
-            <a:r>
-              <a:rPr b="0" lang="en-US" sz="2100" spc="-1" strike="noStrike">
-                <a:solidFill>
-                  <a:srgbClr val="e5edf6"/>
-                </a:solidFill>
-                <a:latin typeface="DejaVu Sans"/>
-              </a:rPr>
-              <a:t>read / write / ioctl / proc / sys</a:t>
+              <a:t>Рабочий поток ядра</a:t>
+            </a:r>
+            <a:endParaRPr b="0" lang="en-US" sz="2100" spc="-1" strike="noStrike">
+              <a:solidFill>
+                <a:srgbClr val="ffffff"/>
+              </a:solidFill>
+              <a:latin typeface="Arial"/>
+            </a:endParaRPr>
+          </a:p>
+          <a:p>
+            <a:r>
+              <a:rPr b="0" lang="en-US" sz="2100" spc="-1" strike="noStrike">
+                <a:solidFill>
+                  <a:srgbClr val="e5edf6"/>
+                </a:solidFill>
+                <a:latin typeface="DejaVu Sans"/>
+              </a:rPr>
+              <a:t>Вызывает vb_command_work</a:t>
+            </a:r>
+            <a:endParaRPr b="0" lang="en-US" sz="2100" spc="-1" strike="noStrike">
+              <a:solidFill>
+                <a:srgbClr val="ffffff"/>
+              </a:solidFill>
+              <a:latin typeface="Arial"/>
+            </a:endParaRPr>
+          </a:p>
+          <a:p>
+            <a:r>
+              <a:rPr b="0" lang="en-US" sz="2100" spc="-1" strike="noStrike">
+                <a:solidFill>
+                  <a:srgbClr val="e5edf6"/>
+                </a:solidFill>
+                <a:latin typeface="DejaVu Sans"/>
+              </a:rPr>
+              <a:t>Применяет команды платы</a:t>
+            </a:r>
+            <a:endParaRPr b="0" lang="en-US" sz="2100" spc="-1" strike="noStrike">
+              <a:solidFill>
+                <a:srgbClr val="ffffff"/>
+              </a:solidFill>
+              <a:latin typeface="Arial"/>
+            </a:endParaRPr>
+          </a:p>
+          <a:p>
+            <a:r>
+              <a:rPr b="0" lang="en-US" sz="2100" spc="-1" strike="noStrike">
+                <a:solidFill>
+                  <a:srgbClr val="e5edf6"/>
+                </a:solidFill>
+                <a:latin typeface="DejaVu Sans"/>
+              </a:rPr>
+              <a:t>state_lock защищает состояние</a:t>
+            </a:r>
+            <a:endParaRPr b="0" lang="en-US" sz="2100" spc="-1" strike="noStrike">
+              <a:solidFill>
+                <a:srgbClr val="ffffff"/>
+              </a:solidFill>
+              <a:latin typeface="Arial"/>
+            </a:endParaRPr>
+          </a:p>
+          <a:p>
+            <a:r>
+              <a:rPr b="0" lang="en-US" sz="2100" spc="-1" strike="noStrike">
+                <a:solidFill>
+                  <a:srgbClr val="e5edf6"/>
+                </a:solidFill>
+                <a:latin typeface="DejaVu Sans"/>
+              </a:rPr>
+              <a:t>Записывает результат заявки</a:t>
+            </a:r>
+            <a:endParaRPr b="0" lang="en-US" sz="2100" spc="-1" strike="noStrike">
+              <a:solidFill>
+                <a:srgbClr val="ffffff"/>
+              </a:solidFill>
+              <a:latin typeface="Arial"/>
+            </a:endParaRPr>
+          </a:p>
+          <a:p>
+            <a:r>
+              <a:rPr b="0" lang="en-US" sz="2100" spc="-1" strike="noStrike">
+                <a:solidFill>
+                  <a:srgbClr val="e5edf6"/>
+                </a:solidFill>
+                <a:latin typeface="DejaVu Sans"/>
+              </a:rPr>
+              <a:t>complete → будит отправителя</a:t>
             </a:r>
             <a:endParaRPr b="0" lang="en-US" sz="2100" spc="-1" strike="noStrike">
               <a:solidFill>
@@ -3633,7 +3633,7 @@
                 </a:solidFill>
                 <a:latin typeface="DejaVu Sans"/>
               </a:rPr>
-              <a:t>Механизмы адаптируем по мере реализации и проверяем на целевом ядре.</a:t>
+              <a:t>Основа: ДЗ14 — ordered workqueue; лекция 31 — work + completion.</a:t>
             </a:r>
             <a:endParaRPr b="0" lang="en-US" sz="1800" spc="-1" strike="noStrike">
               <a:solidFill>
@@ -3796,7 +3796,7 @@
                 </a:solidFill>
                 <a:latin typeface="DejaVu Sans"/>
               </a:rPr>
-              <a:t>Рабочая версия · 18.09.2026 · фактические результаты 17–18.09.2026</a:t>
+              <a:t>Рабочая версия · 21.09.2026 · результаты 17–21.09.2026</a:t>
             </a:r>
             <a:endParaRPr b="0" lang="en-US" sz="1400" spc="-1" strike="noStrike">
               <a:solidFill>
@@ -3924,7 +3924,7 @@
                 </a:solidFill>
                 <a:latin typeface="DejaVu Sans Mono"/>
               </a:rPr>
-              <a:t>Виртуальная шина: cansend → candump</a:t>
+              <a:t>write: temp / limits → workqueue → состояние</a:t>
             </a:r>
             <a:endParaRPr b="0" lang="en-US" sz="1800" spc="-1" strike="noStrike">
               <a:solidFill>
@@ -3941,7 +3941,7 @@
                 </a:solidFill>
                 <a:latin typeface="DejaVu Sans Mono"/>
               </a:rPr>
-              <a:t>vcan0 123 [4] 11 22 33 44</a:t>
+              <a:t>normal → overheat → normal → undertemp</a:t>
             </a:r>
             <a:endParaRPr b="0" lang="en-US" sz="1800" spc="-1" strike="noStrike">
               <a:solidFill>
@@ -3985,7 +3985,7 @@
                 </a:solidFill>
                 <a:latin typeface="DejaVu Sans Mono"/>
               </a:rPr>
-              <a:t>Устройство: /dev/virtual_board → номер 511:0</a:t>
+              <a:t>Обе точные границы температуры — норма</a:t>
             </a:r>
             <a:endParaRPr b="0" lang="en-US" sz="1800" spc="-1" strike="noStrike">
               <a:solidFill>
@@ -4002,7 +4002,7 @@
                 </a:solidFill>
                 <a:latin typeface="DejaVu Sans Mono"/>
               </a:rPr>
-              <a:t>Номер совпал в /dev, sysfs и журнале</a:t>
+              <a:t>3 неверные команды отклонены; затем write работает</a:t>
             </a:r>
             <a:endParaRPr b="0" lang="en-US" sz="1800" spc="-1" strike="noStrike">
               <a:solidFill>
@@ -4061,7 +4061,7 @@
                 </a:solidFill>
                 <a:latin typeface="DejaVu Sans"/>
               </a:rPr>
-              <a:t>Параметры: допустимые значения приняты; неверное имя и 5 числовых несоответствий отклонены. CAN-отправки пока нет.</a:t>
+              <a:t>CAN 0x124: перегрев и возврат в норму. Без повторов; в stopped кадров нет, контроль продолжается.</a:t>
             </a:r>
             <a:endParaRPr b="0" lang="en-US" sz="2100" spc="-1" strike="noStrike">
               <a:solidFill>
@@ -4103,7 +4103,7 @@
                 </a:solidFill>
                 <a:latin typeface="DejaVu Sans"/>
               </a:rPr>
-              <a:t>Требование ядра курса и включение .config пока не закрыты.</a:t>
+              <a:t>До CAN: check — 0 ошибок, 17 замечаний; .config отложена.</a:t>
             </a:r>
             <a:endParaRPr b="0" lang="en-US" sz="1500" spc="-1" strike="noStrike">
               <a:solidFill>
@@ -4266,7 +4266,7 @@
                 </a:solidFill>
                 <a:latin typeface="DejaVu Sans"/>
               </a:rPr>
-              <a:t>Рабочая версия · 18.09.2026 · план; результаты добавим после испытаний</a:t>
+              <a:t>Рабочая версия · 21.09.2026 · план; результаты добавим после испытаний</a:t>
             </a:r>
             <a:endParaRPr b="0" lang="en-US" sz="1400" spc="-1" strike="noStrike">
               <a:solidFill>
@@ -4369,58 +4369,58 @@
                 </a:solidFill>
                 <a:latin typeface="DejaVu Sans"/>
               </a:rPr>
-              <a:t>Общий контекст состояния</a:t>
-            </a:r>
-            <a:endParaRPr b="0" lang="en-US" sz="2100" spc="-1" strike="noStrike">
-              <a:solidFill>
-                <a:srgbClr val="ffffff"/>
-              </a:solidFill>
-              <a:latin typeface="Arial"/>
-            </a:endParaRPr>
-          </a:p>
-          <a:p>
-            <a:r>
-              <a:rPr b="0" lang="en-US" sz="2100" spc="-1" strike="noStrike">
-                <a:solidFill>
-                  <a:srgbClr val="e5edf6"/>
-                </a:solidFill>
-                <a:latin typeface="DejaVu Sans"/>
-              </a:rPr>
-              <a:t>Приём команды через write</a:t>
-            </a:r>
-            <a:endParaRPr b="0" lang="en-US" sz="2100" spc="-1" strike="noStrike">
-              <a:solidFill>
-                <a:srgbClr val="ffffff"/>
-              </a:solidFill>
-              <a:latin typeface="Arial"/>
-            </a:endParaRPr>
-          </a:p>
-          <a:p>
-            <a:r>
-              <a:rPr b="0" lang="en-US" sz="2100" spc="-1" strike="noStrike">
-                <a:solidFill>
-                  <a:srgbClr val="e5edf6"/>
-                </a:solidFill>
-                <a:latin typeface="DejaVu Sans"/>
-              </a:rPr>
-              <a:t>Первую отправку CAN</a:t>
-            </a:r>
-            <a:endParaRPr b="0" lang="en-US" sz="2100" spc="-1" strike="noStrike">
-              <a:solidFill>
-                <a:srgbClr val="ffffff"/>
-              </a:solidFill>
-              <a:latin typeface="Arial"/>
-            </a:endParaRPr>
-          </a:p>
-          <a:p>
-            <a:r>
-              <a:rPr b="0" lang="en-US" sz="2100" spc="-1" strike="noStrike">
-                <a:solidFill>
-                  <a:srgbClr val="e5edf6"/>
-                </a:solidFill>
-                <a:latin typeface="DejaVu Sans"/>
-              </a:rPr>
-              <a:t>Температурную логику и FIFO</a:t>
+              <a:t>Таймер и статус 0x123</a:t>
+            </a:r>
+            <a:endParaRPr b="0" lang="en-US" sz="2100" spc="-1" strike="noStrike">
+              <a:solidFill>
+                <a:srgbClr val="ffffff"/>
+              </a:solidFill>
+              <a:latin typeface="Arial"/>
+            </a:endParaRPr>
+          </a:p>
+          <a:p>
+            <a:r>
+              <a:rPr b="0" lang="en-US" sz="2100" spc="-1" strike="noStrike">
+                <a:solidFill>
+                  <a:srgbClr val="e5edf6"/>
+                </a:solidFill>
+                <a:latin typeface="DejaVu Sans"/>
+              </a:rPr>
+              <a:t>Проверка периода в candump</a:t>
+            </a:r>
+            <a:endParaRPr b="0" lang="en-US" sz="2100" spc="-1" strike="noStrike">
+              <a:solidFill>
+                <a:srgbClr val="ffffff"/>
+              </a:solidFill>
+              <a:latin typeface="Arial"/>
+            </a:endParaRPr>
+          </a:p>
+          <a:p>
+            <a:r>
+              <a:rPr b="0" lang="en-US" sz="2100" spc="-1" strike="noStrike">
+                <a:solidFill>
+                  <a:srgbClr val="e5edf6"/>
+                </a:solidFill>
+                <a:latin typeface="DejaVu Sans"/>
+              </a:rPr>
+              <a:t>Таймер: start / stop</a:t>
+            </a:r>
+            <a:endParaRPr b="0" lang="en-US" sz="2100" spc="-1" strike="noStrike">
+              <a:solidFill>
+                <a:srgbClr val="ffffff"/>
+              </a:solidFill>
+              <a:latin typeface="Arial"/>
+            </a:endParaRPr>
+          </a:p>
+          <a:p>
+            <a:r>
+              <a:rPr b="0" lang="en-US" sz="2100" spc="-1" strike="noStrike">
+                <a:solidFill>
+                  <a:srgbClr val="e5edf6"/>
+                </a:solidFill>
+                <a:latin typeface="DejaVu Sans"/>
+              </a:rPr>
+              <a:t>Персональные FIFO и read</a:t>
             </a:r>
             <a:endParaRPr b="0" lang="en-US" sz="2100" spc="-1" strike="noStrike">
               <a:solidFill>

</xml_diff>

<commit_message>
Add hrtimer-based periodic CAN status transmission
 - Send status frames 0x123 through the ordered workqueue
 - Start and cancel the timer with start/stop commands
 - Cancel the timer before destroying the workqueue
 - Verify one-second transmission, stop, restart and unload
 - Update documentation and presentation with test results
</commit_message>
<xml_diff>
--- a/docs/presentation/virtual_board.pptx
+++ b/docs/presentation/virtual_board.pptx
@@ -1469,7 +1469,7 @@
                 </a:solidFill>
                 <a:latin typeface="DejaVu Sans"/>
               </a:rPr>
-              <a:t>Рабочая версия · 21.09.2026 · первый CAN-кадр проверен</a:t>
+              <a:t>Рабочая версия · 21.09.2026 · статус и переходы получены</a:t>
             </a:r>
             <a:endParaRPr b="0" lang="en-US" sz="1400" spc="-1" strike="noStrike">
               <a:solidFill>
@@ -1879,7 +1879,7 @@
                 </a:solidFill>
                 <a:latin typeface="DejaVu Sans"/>
               </a:rPr>
-              <a:t>Кадры 0x124 получены в candump.</a:t>
+              <a:t>Кадры 0x123 и 0x124 получены в candump.</a:t>
             </a:r>
             <a:endParaRPr b="0" lang="en-US" sz="2100" spc="-1" strike="noStrike">
               <a:solidFill>
@@ -4061,7 +4061,7 @@
                 </a:solidFill>
                 <a:latin typeface="DejaVu Sans"/>
               </a:rPr>
-              <a:t>CAN 0x124: перегрев и возврат в норму. Без повторов; в stopped кадров нет, контроль продолжается.</a:t>
+              <a:t>CAN: 0x124 — переходы; 0x123 — статус раз в секунду. stop и перезапуск проверены. Выгрузка успешна.</a:t>
             </a:r>
             <a:endParaRPr b="0" lang="en-US" sz="2100" spc="-1" strike="noStrike">
               <a:solidFill>
@@ -4352,58 +4352,58 @@
                 </a:solidFill>
                 <a:latin typeface="DejaVu Sans"/>
               </a:rPr>
-              <a:t>РЕАЛИЗОВАТЬ</a:t>
-            </a:r>
-            <a:endParaRPr b="0" lang="en-US" sz="2100" spc="-1" strike="noStrike">
-              <a:solidFill>
-                <a:srgbClr val="ffffff"/>
-              </a:solidFill>
-              <a:latin typeface="Arial"/>
-            </a:endParaRPr>
-          </a:p>
-          <a:p>
-            <a:r>
-              <a:rPr b="0" lang="en-US" sz="2100" spc="-1" strike="noStrike">
-                <a:solidFill>
-                  <a:srgbClr val="e5edf6"/>
-                </a:solidFill>
-                <a:latin typeface="DejaVu Sans"/>
-              </a:rPr>
-              <a:t>Таймер и статус 0x123</a:t>
-            </a:r>
-            <a:endParaRPr b="0" lang="en-US" sz="2100" spc="-1" strike="noStrike">
-              <a:solidFill>
-                <a:srgbClr val="ffffff"/>
-              </a:solidFill>
-              <a:latin typeface="Arial"/>
-            </a:endParaRPr>
-          </a:p>
-          <a:p>
-            <a:r>
-              <a:rPr b="0" lang="en-US" sz="2100" spc="-1" strike="noStrike">
-                <a:solidFill>
-                  <a:srgbClr val="e5edf6"/>
-                </a:solidFill>
-                <a:latin typeface="DejaVu Sans"/>
-              </a:rPr>
-              <a:t>Проверка периода в candump</a:t>
-            </a:r>
-            <a:endParaRPr b="0" lang="en-US" sz="2100" spc="-1" strike="noStrike">
-              <a:solidFill>
-                <a:srgbClr val="ffffff"/>
-              </a:solidFill>
-              <a:latin typeface="Arial"/>
-            </a:endParaRPr>
-          </a:p>
-          <a:p>
-            <a:r>
-              <a:rPr b="0" lang="en-US" sz="2100" spc="-1" strike="noStrike">
-                <a:solidFill>
-                  <a:srgbClr val="e5edf6"/>
-                </a:solidFill>
-                <a:latin typeface="DejaVu Sans"/>
-              </a:rPr>
-              <a:t>Таймер: start / stop</a:t>
+              <a:t>ПРОВЕРИТЬ / РЕАЛИЗОВАТЬ</a:t>
+            </a:r>
+            <a:endParaRPr b="0" lang="en-US" sz="2100" spc="-1" strike="noStrike">
+              <a:solidFill>
+                <a:srgbClr val="ffffff"/>
+              </a:solidFill>
+              <a:latin typeface="Arial"/>
+            </a:endParaRPr>
+          </a:p>
+          <a:p>
+            <a:r>
+              <a:rPr b="0" lang="en-US" sz="2100" spc="-1" strike="noStrike">
+                <a:solidFill>
+                  <a:srgbClr val="e5edf6"/>
+                </a:solidFill>
+                <a:latin typeface="DejaVu Sans"/>
+              </a:rPr>
+              <a:t>Совместную работу 0x123 / 0x124</a:t>
+            </a:r>
+            <a:endParaRPr b="0" lang="en-US" sz="2100" spc="-1" strike="noStrike">
+              <a:solidFill>
+                <a:srgbClr val="ffffff"/>
+              </a:solidFill>
+              <a:latin typeface="Arial"/>
+            </a:endParaRPr>
+          </a:p>
+          <a:p>
+            <a:r>
+              <a:rPr b="0" lang="en-US" sz="2100" spc="-1" strike="noStrike">
+                <a:solidFill>
+                  <a:srgbClr val="e5edf6"/>
+                </a:solidFill>
+                <a:latin typeface="DejaVu Sans"/>
+              </a:rPr>
+              <a:t>Период по умолчанию: 100 мс</a:t>
+            </a:r>
+            <a:endParaRPr b="0" lang="en-US" sz="2100" spc="-1" strike="noStrike">
+              <a:solidFill>
+                <a:srgbClr val="ffffff"/>
+              </a:solidFill>
+              <a:latin typeface="Arial"/>
+            </a:endParaRPr>
+          </a:p>
+          <a:p>
+            <a:r>
+              <a:rPr b="0" lang="en-US" sz="2100" spc="-1" strike="noStrike">
+                <a:solidFill>
+                  <a:srgbClr val="e5edf6"/>
+                </a:solidFill>
+                <a:latin typeface="DejaVu Sans"/>
+              </a:rPr>
+              <a:t>Повторные start / stop</a:t>
             </a:r>
             <a:endParaRPr b="0" lang="en-US" sz="2100" spc="-1" strike="noStrike">
               <a:solidFill>

</xml_diff>

<commit_message>
• Add procfs/sysfs monitoring and CAN error events
 - Expose state and temperature status through read-only sysfs attributes
 - Add procfs snapshots with board state and per-client event losses
 - Publish CAN_ERROR events and suppress repeated identical errors
 - Verify CAN recovery after interface down/up without restarting the board
 - Verify client lifecycle and interface cleanup on unload
 - Update documentation and presentation with demonstrated results
</commit_message>
<xml_diff>
--- a/docs/presentation/virtual_board.pptx
+++ b/docs/presentation/virtual_board.pptx
@@ -18,6 +18,9 @@
     <p:sldId id="266" r:id="rId13"/>
     <p:sldId id="267" r:id="rId14"/>
     <p:sldId id="268" r:id="rId15"/>
+    <p:sldId id="269" r:id="rId16"/>
+    <p:sldId id="270" r:id="rId17"/>
+    <p:sldId id="271" r:id="rId18"/>
   </p:sldIdLst>
   <p:sldSz cx="12192000" cy="6858000"/>
   <p:notesSz cx="7559675" cy="10691813"/>
@@ -1804,7 +1807,7 @@
                 </a:solidFill>
                 <a:latin typeface="Arial"/>
               </a:rPr>
-              <a:t>Параметры → состояние → CAN → workqueue/таймер → cdev/class/device</a:t>
+              <a:t>Параметры → CAN → workqueue/таймер → устройство → sysfs</a:t>
             </a:r>
             <a:endParaRPr b="0" lang="en-US" sz="2100" spc="-1" strike="noStrike">
               <a:solidFill>
@@ -2494,7 +2497,7 @@
                 </a:solidFill>
                 <a:latin typeface="Arial"/>
               </a:rPr>
-              <a:t>Частичная регистрация откатывается внутри vb_chardev_init.</a:t>
+              <a:t>Ошибка sysfs: убрать атрибуты → устройство → класс → cdev → номер.</a:t>
             </a:r>
             <a:endParaRPr b="0" lang="en-US" sz="2100" spc="-1" strike="noStrike">
               <a:solidFill>
@@ -2961,7 +2964,7 @@
         <p:spPr>
           <a:xfrm>
             <a:off x="576000" y="2880000"/>
-            <a:ext cx="2340000" cy="368640"/>
+            <a:ext cx="2340000" cy="646920"/>
           </a:xfrm>
           <a:prstGeom prst="rect">
             <a:avLst/>
@@ -2991,7 +2994,7 @@
                 </a:solidFill>
                 <a:latin typeface="Arial"/>
               </a:rPr>
-              <a:t>Убрать /dev</a:t>
+              <a:t>Убрать интерфейсы</a:t>
             </a:r>
             <a:endParaRPr b="0" lang="en-US" sz="1700" spc="-1" strike="noStrike">
               <a:solidFill>
@@ -3041,7 +3044,7 @@
                 </a:solidFill>
                 <a:latin typeface="Arial"/>
               </a:rPr>
-              <a:t>Удалить регистрацию</a:t>
+              <a:t>Снять sysfs, затем</a:t>
             </a:r>
             <a:endParaRPr b="0" lang="en-US" sz="1600" spc="-1" strike="noStrike">
               <a:solidFill>
@@ -3066,7 +3069,7 @@
                 </a:solidFill>
                 <a:latin typeface="Arial"/>
               </a:rPr>
-              <a:t>устройства</a:t>
+              <a:t>удалить устройство</a:t>
             </a:r>
             <a:endParaRPr b="0" lang="en-US" sz="1600" spc="-1" strike="noStrike">
               <a:solidFill>
@@ -4846,7 +4849,7 @@
                 </a:solidFill>
                 <a:latin typeface="Arial"/>
               </a:rPr>
-              <a:t>Новая проверка FIFO/ioctl показана отдельно; proc/sys-атрибуты ещё не готовы.</a:t>
+              <a:t>FIFO/ioctl и proc/sys показаны в отдельных сценариях.</a:t>
             </a:r>
             <a:endParaRPr b="0" lang="en-US" sz="1700" spc="-1" strike="noStrike">
               <a:solidFill>
@@ -5845,6 +5848,2931 @@
 </p:sld>
 </file>
 
+<file path=ppt/slides/slide14.xml><?xml version="1.0" encoding="utf-8"?>
+<p:sld xmlns:a="http://schemas.openxmlformats.org/drawingml/2006/main" xmlns:p="http://schemas.openxmlformats.org/presentationml/2006/main" xmlns:r="http://schemas.openxmlformats.org/officeDocument/2006/relationships" xmlns:p14="http://schemas.microsoft.com/office/powerpoint/2010/main" xmlns:p15="http://schemas.microsoft.com/office/powerpoint/2012/main" xmlns:mc="http://schemas.openxmlformats.org/markup-compatibility/2006">
+  <p:cSld>
+    <p:bg>
+      <p:bgPr>
+        <a:solidFill>
+          <a:srgbClr val="101d2d"/>
+        </a:solidFill>
+      </p:bgPr>
+    </p:bg>
+    <p:spTree>
+      <p:nvGrpSpPr>
+        <p:cNvPr id="1" name=""/>
+        <p:cNvGrpSpPr/>
+        <p:nvPr/>
+      </p:nvGrpSpPr>
+      <p:grpSpPr>
+        <a:xfrm>
+          <a:off x="0" y="0"/>
+          <a:ext cx="0" cy="0"/>
+          <a:chOff x="0" y="0"/>
+          <a:chExt cx="0" cy="0"/>
+        </a:xfrm>
+      </p:grpSpPr>
+      <p:sp>
+        <p:nvSpPr>
+          <p:cNvPr id="263" name=""/>
+          <p:cNvSpPr txBox="1"/>
+          <p:nvPr/>
+        </p:nvSpPr>
+        <p:spPr>
+          <a:xfrm>
+            <a:off x="432000" y="162000"/>
+            <a:ext cx="11160000" cy="286560"/>
+          </a:xfrm>
+          <a:prstGeom prst="rect">
+            <a:avLst/>
+          </a:prstGeom>
+          <a:noFill/>
+          <a:ln w="0">
+            <a:noFill/>
+          </a:ln>
+        </p:spPr>
+        <p:txBody>
+          <a:bodyPr lIns="90000" rIns="90000" tIns="45000" bIns="45000" anchor="t">
+            <a:noAutofit/>
+          </a:bodyPr>
+          <a:p>
+            <a:pPr>
+              <a:lnSpc>
+                <a:spcPct val="115000"/>
+              </a:lnSpc>
+              <a:spcAft>
+                <a:spcPts val="482"/>
+              </a:spcAft>
+            </a:pPr>
+            <a:r>
+              <a:rPr b="1" lang="en-US" sz="1200" spc="-1" strike="noStrike">
+                <a:solidFill>
+                  <a:srgbClr val="46d4c4"/>
+                </a:solidFill>
+                <a:latin typeface="Arial"/>
+              </a:rPr>
+              <a:t>VIRTUAL BOARD / АНДРЕЙ ЮНИН / OTUS · LINUX KERNEL</a:t>
+            </a:r>
+            <a:endParaRPr b="0" lang="en-US" sz="1200" spc="-1" strike="noStrike">
+              <a:solidFill>
+                <a:srgbClr val="ffffff"/>
+              </a:solidFill>
+              <a:latin typeface="Arial"/>
+            </a:endParaRPr>
+          </a:p>
+        </p:txBody>
+      </p:sp>
+      <p:sp>
+        <p:nvSpPr>
+          <p:cNvPr id="264" name=""/>
+          <p:cNvSpPr txBox="1"/>
+          <p:nvPr/>
+        </p:nvSpPr>
+        <p:spPr>
+          <a:xfrm>
+            <a:off x="432000" y="486000"/>
+            <a:ext cx="11304000" cy="612000"/>
+          </a:xfrm>
+          <a:prstGeom prst="rect">
+            <a:avLst/>
+          </a:prstGeom>
+          <a:noFill/>
+          <a:ln w="0">
+            <a:noFill/>
+          </a:ln>
+        </p:spPr>
+        <p:txBody>
+          <a:bodyPr lIns="90000" rIns="90000" tIns="45000" bIns="45000" anchor="t">
+            <a:noAutofit/>
+          </a:bodyPr>
+          <a:p>
+            <a:pPr>
+              <a:lnSpc>
+                <a:spcPct val="115000"/>
+              </a:lnSpc>
+              <a:spcAft>
+                <a:spcPts val="482"/>
+              </a:spcAft>
+            </a:pPr>
+            <a:r>
+              <a:rPr b="1" lang="en-US" sz="3000" spc="-1" strike="noStrike">
+                <a:solidFill>
+                  <a:srgbClr val="ffffff"/>
+                </a:solidFill>
+                <a:latin typeface="Arial"/>
+              </a:rPr>
+              <a:t>Sysfs: состояние сейчас, read: события</a:t>
+            </a:r>
+            <a:endParaRPr b="0" lang="en-US" sz="3000" spc="-1" strike="noStrike">
+              <a:solidFill>
+                <a:srgbClr val="ffffff"/>
+              </a:solidFill>
+              <a:latin typeface="Arial"/>
+            </a:endParaRPr>
+          </a:p>
+        </p:txBody>
+      </p:sp>
+      <p:sp>
+        <p:nvSpPr>
+          <p:cNvPr id="265" name=""/>
+          <p:cNvSpPr txBox="1"/>
+          <p:nvPr/>
+        </p:nvSpPr>
+        <p:spPr>
+          <a:xfrm>
+            <a:off x="432000" y="6498000"/>
+            <a:ext cx="10440000" cy="349920"/>
+          </a:xfrm>
+          <a:prstGeom prst="rect">
+            <a:avLst/>
+          </a:prstGeom>
+          <a:noFill/>
+          <a:ln w="0">
+            <a:noFill/>
+          </a:ln>
+        </p:spPr>
+        <p:txBody>
+          <a:bodyPr lIns="90000" rIns="90000" tIns="45000" bIns="45000" anchor="t">
+            <a:noAutofit/>
+          </a:bodyPr>
+          <a:p>
+            <a:pPr>
+              <a:lnSpc>
+                <a:spcPct val="115000"/>
+              </a:lnSpc>
+              <a:spcAft>
+                <a:spcPts val="482"/>
+              </a:spcAft>
+            </a:pPr>
+            <a:r>
+              <a:rPr b="0" lang="en-US" sz="1600" spc="-1" strike="noStrike">
+                <a:solidFill>
+                  <a:srgbClr val="aebccd"/>
+                </a:solidFill>
+                <a:latin typeface="Arial"/>
+              </a:rPr>
+              <a:t>Источник: проверка пользователя 22.09; пределы 100–700, температура 850</a:t>
+            </a:r>
+            <a:endParaRPr b="0" lang="en-US" sz="1600" spc="-1" strike="noStrike">
+              <a:solidFill>
+                <a:srgbClr val="ffffff"/>
+              </a:solidFill>
+              <a:latin typeface="Arial"/>
+            </a:endParaRPr>
+          </a:p>
+        </p:txBody>
+      </p:sp>
+      <p:sp>
+        <p:nvSpPr>
+          <p:cNvPr id="266" name=""/>
+          <p:cNvSpPr txBox="1"/>
+          <p:nvPr/>
+        </p:nvSpPr>
+        <p:spPr>
+          <a:xfrm>
+            <a:off x="11160000" y="6498000"/>
+            <a:ext cx="540000" cy="349920"/>
+          </a:xfrm>
+          <a:prstGeom prst="rect">
+            <a:avLst/>
+          </a:prstGeom>
+          <a:noFill/>
+          <a:ln w="0">
+            <a:noFill/>
+          </a:ln>
+        </p:spPr>
+        <p:txBody>
+          <a:bodyPr lIns="90000" rIns="90000" tIns="45000" bIns="45000" anchor="t">
+            <a:noAutofit/>
+          </a:bodyPr>
+          <a:p>
+            <a:pPr>
+              <a:lnSpc>
+                <a:spcPct val="115000"/>
+              </a:lnSpc>
+              <a:spcAft>
+                <a:spcPts val="482"/>
+              </a:spcAft>
+            </a:pPr>
+            <a:r>
+              <a:rPr b="0" lang="en-US" sz="1600" spc="-1" strike="noStrike">
+                <a:solidFill>
+                  <a:srgbClr val="aebccd"/>
+                </a:solidFill>
+                <a:latin typeface="Arial"/>
+              </a:rPr>
+              <a:t>14</a:t>
+            </a:r>
+            <a:endParaRPr b="0" lang="en-US" sz="1600" spc="-1" strike="noStrike">
+              <a:solidFill>
+                <a:srgbClr val="ffffff"/>
+              </a:solidFill>
+              <a:latin typeface="Arial"/>
+            </a:endParaRPr>
+          </a:p>
+        </p:txBody>
+      </p:sp>
+      <p:sp>
+        <p:nvSpPr>
+          <p:cNvPr id="267" name=""/>
+          <p:cNvSpPr/>
+          <p:nvPr/>
+        </p:nvSpPr>
+        <p:spPr>
+          <a:xfrm>
+            <a:off x="432000" y="1332000"/>
+            <a:ext cx="11304000" cy="1584000"/>
+          </a:xfrm>
+          <a:prstGeom prst="rect">
+            <a:avLst/>
+          </a:prstGeom>
+          <a:solidFill>
+            <a:srgbClr val="173e43"/>
+          </a:solidFill>
+          <a:ln w="0">
+            <a:noFill/>
+          </a:ln>
+        </p:spPr>
+        <p:txBody>
+          <a:bodyPr lIns="90000" rIns="90000" tIns="45000" bIns="45000" anchor="t">
+            <a:noAutofit/>
+          </a:bodyPr>
+          <a:p>
+            <a:endParaRPr b="0" lang="en-US" sz="1800" spc="-1" strike="noStrike">
+              <a:solidFill>
+                <a:srgbClr val="ffffff"/>
+              </a:solidFill>
+              <a:latin typeface="Arial"/>
+            </a:endParaRPr>
+          </a:p>
+        </p:txBody>
+      </p:sp>
+      <p:sp>
+        <p:nvSpPr>
+          <p:cNvPr id="268" name=""/>
+          <p:cNvSpPr txBox="1"/>
+          <p:nvPr/>
+        </p:nvSpPr>
+        <p:spPr>
+          <a:xfrm>
+            <a:off x="576000" y="1440000"/>
+            <a:ext cx="11016000" cy="368640"/>
+          </a:xfrm>
+          <a:prstGeom prst="rect">
+            <a:avLst/>
+          </a:prstGeom>
+          <a:noFill/>
+          <a:ln w="0">
+            <a:noFill/>
+          </a:ln>
+        </p:spPr>
+        <p:txBody>
+          <a:bodyPr lIns="90000" rIns="90000" tIns="45000" bIns="45000" anchor="t">
+            <a:noAutofit/>
+          </a:bodyPr>
+          <a:p>
+            <a:pPr>
+              <a:lnSpc>
+                <a:spcPct val="115000"/>
+              </a:lnSpc>
+              <a:spcAft>
+                <a:spcPts val="482"/>
+              </a:spcAft>
+            </a:pPr>
+            <a:r>
+              <a:rPr b="1" lang="en-US" sz="1700" spc="-1" strike="noStrike">
+                <a:solidFill>
+                  <a:srgbClr val="46d4c4"/>
+                </a:solidFill>
+                <a:latin typeface="Arial"/>
+              </a:rPr>
+              <a:t>КОМАНДА ЧЕРЕЗ /dev → board.status → ЧТЕНИЕ SYSFS</a:t>
+            </a:r>
+            <a:endParaRPr b="0" lang="en-US" sz="1700" spc="-1" strike="noStrike">
+              <a:solidFill>
+                <a:srgbClr val="ffffff"/>
+              </a:solidFill>
+              <a:latin typeface="Arial"/>
+            </a:endParaRPr>
+          </a:p>
+        </p:txBody>
+      </p:sp>
+      <p:sp>
+        <p:nvSpPr>
+          <p:cNvPr id="269" name=""/>
+          <p:cNvSpPr txBox="1"/>
+          <p:nvPr/>
+        </p:nvSpPr>
+        <p:spPr>
+          <a:xfrm>
+            <a:off x="576000" y="1782000"/>
+            <a:ext cx="11016000" cy="1080000"/>
+          </a:xfrm>
+          <a:prstGeom prst="rect">
+            <a:avLst/>
+          </a:prstGeom>
+          <a:noFill/>
+          <a:ln w="0">
+            <a:noFill/>
+          </a:ln>
+        </p:spPr>
+        <p:txBody>
+          <a:bodyPr lIns="90000" rIns="90000" tIns="45000" bIns="45000" anchor="t">
+            <a:noAutofit/>
+          </a:bodyPr>
+          <a:p>
+            <a:endParaRPr b="0" lang="en-US" sz="1800" spc="-1" strike="noStrike">
+              <a:solidFill>
+                <a:srgbClr val="ffffff"/>
+              </a:solidFill>
+              <a:latin typeface="Arial"/>
+            </a:endParaRPr>
+          </a:p>
+        </p:txBody>
+      </p:sp>
+      <p:sp>
+        <p:nvSpPr>
+          <p:cNvPr id="270" name=""/>
+          <p:cNvSpPr txBox="1"/>
+          <p:nvPr/>
+        </p:nvSpPr>
+        <p:spPr>
+          <a:xfrm>
+            <a:off x="648000" y="1800000"/>
+            <a:ext cx="10800000" cy="813240"/>
+          </a:xfrm>
+          <a:prstGeom prst="rect">
+            <a:avLst/>
+          </a:prstGeom>
+          <a:noFill/>
+          <a:ln w="0">
+            <a:noFill/>
+          </a:ln>
+        </p:spPr>
+        <p:txBody>
+          <a:bodyPr lIns="90000" rIns="90000" tIns="45000" bIns="45000" anchor="t">
+            <a:noAutofit/>
+          </a:bodyPr>
+          <a:p>
+            <a:pPr>
+              <a:lnSpc>
+                <a:spcPct val="115000"/>
+              </a:lnSpc>
+              <a:spcAft>
+                <a:spcPts val="482"/>
+              </a:spcAft>
+            </a:pPr>
+            <a:r>
+              <a:rPr b="0" lang="en-US" sz="2000" spc="-1" strike="noStrike">
+                <a:solidFill>
+                  <a:srgbClr val="e8eef5"/>
+                </a:solidFill>
+                <a:latin typeface="Courier New"/>
+              </a:rPr>
+              <a:t>После загрузки: state = stopped; temp_status = normal</a:t>
+            </a:r>
+            <a:endParaRPr b="0" lang="en-US" sz="2000" spc="-1" strike="noStrike">
+              <a:solidFill>
+                <a:srgbClr val="ffffff"/>
+              </a:solidFill>
+              <a:latin typeface="Arial"/>
+            </a:endParaRPr>
+          </a:p>
+          <a:p>
+            <a:pPr>
+              <a:lnSpc>
+                <a:spcPct val="115000"/>
+              </a:lnSpc>
+              <a:spcAft>
+                <a:spcPts val="482"/>
+              </a:spcAft>
+            </a:pPr>
+            <a:r>
+              <a:rPr b="0" lang="en-US" sz="2000" spc="-1" strike="noStrike">
+                <a:solidFill>
+                  <a:srgbClr val="e8eef5"/>
+                </a:solidFill>
+                <a:latin typeface="Courier New"/>
+              </a:rPr>
+              <a:t>start → running; temp 850 → running / overheat</a:t>
+            </a:r>
+            <a:endParaRPr b="0" lang="en-US" sz="2000" spc="-1" strike="noStrike">
+              <a:solidFill>
+                <a:srgbClr val="ffffff"/>
+              </a:solidFill>
+              <a:latin typeface="Arial"/>
+            </a:endParaRPr>
+          </a:p>
+        </p:txBody>
+      </p:sp>
+      <p:sp>
+        <p:nvSpPr>
+          <p:cNvPr id="271" name=""/>
+          <p:cNvSpPr txBox="1"/>
+          <p:nvPr/>
+        </p:nvSpPr>
+        <p:spPr>
+          <a:xfrm>
+            <a:off x="648000" y="2592000"/>
+            <a:ext cx="10800000" cy="349920"/>
+          </a:xfrm>
+          <a:prstGeom prst="rect">
+            <a:avLst/>
+          </a:prstGeom>
+          <a:noFill/>
+          <a:ln w="0">
+            <a:noFill/>
+          </a:ln>
+        </p:spPr>
+        <p:txBody>
+          <a:bodyPr lIns="90000" rIns="90000" tIns="45000" bIns="45000" anchor="t">
+            <a:noAutofit/>
+          </a:bodyPr>
+          <a:p>
+            <a:pPr>
+              <a:lnSpc>
+                <a:spcPct val="115000"/>
+              </a:lnSpc>
+              <a:spcAft>
+                <a:spcPts val="482"/>
+              </a:spcAft>
+            </a:pPr>
+            <a:r>
+              <a:rPr b="0" lang="en-US" sz="1600" spc="-1" strike="noStrike">
+                <a:solidFill>
+                  <a:srgbClr val="aebccd"/>
+                </a:solidFill>
+                <a:latin typeface="Arial"/>
+              </a:rPr>
+              <a:t>stop → stopped / overheat: передача остановлена, перегрев сохраняется.</a:t>
+            </a:r>
+            <a:endParaRPr b="0" lang="en-US" sz="1600" spc="-1" strike="noStrike">
+              <a:solidFill>
+                <a:srgbClr val="ffffff"/>
+              </a:solidFill>
+              <a:latin typeface="Arial"/>
+            </a:endParaRPr>
+          </a:p>
+        </p:txBody>
+      </p:sp>
+      <p:sp>
+        <p:nvSpPr>
+          <p:cNvPr id="272" name=""/>
+          <p:cNvSpPr/>
+          <p:nvPr/>
+        </p:nvSpPr>
+        <p:spPr>
+          <a:xfrm>
+            <a:off x="432000" y="3204000"/>
+            <a:ext cx="5436000" cy="2160000"/>
+          </a:xfrm>
+          <a:prstGeom prst="rect">
+            <a:avLst/>
+          </a:prstGeom>
+          <a:solidFill>
+            <a:srgbClr val="203248"/>
+          </a:solidFill>
+          <a:ln w="0">
+            <a:noFill/>
+          </a:ln>
+        </p:spPr>
+        <p:txBody>
+          <a:bodyPr lIns="90000" rIns="90000" tIns="45000" bIns="45000" anchor="t">
+            <a:noAutofit/>
+          </a:bodyPr>
+          <a:p>
+            <a:endParaRPr b="0" lang="en-US" sz="1800" spc="-1" strike="noStrike">
+              <a:solidFill>
+                <a:srgbClr val="ffffff"/>
+              </a:solidFill>
+              <a:latin typeface="Arial"/>
+            </a:endParaRPr>
+          </a:p>
+        </p:txBody>
+      </p:sp>
+      <p:sp>
+        <p:nvSpPr>
+          <p:cNvPr id="273" name=""/>
+          <p:cNvSpPr txBox="1"/>
+          <p:nvPr/>
+        </p:nvSpPr>
+        <p:spPr>
+          <a:xfrm>
+            <a:off x="576000" y="3312000"/>
+            <a:ext cx="5148000" cy="368640"/>
+          </a:xfrm>
+          <a:prstGeom prst="rect">
+            <a:avLst/>
+          </a:prstGeom>
+          <a:noFill/>
+          <a:ln w="0">
+            <a:noFill/>
+          </a:ln>
+        </p:spPr>
+        <p:txBody>
+          <a:bodyPr lIns="90000" rIns="90000" tIns="45000" bIns="45000" anchor="t">
+            <a:noAutofit/>
+          </a:bodyPr>
+          <a:p>
+            <a:pPr>
+              <a:lnSpc>
+                <a:spcPct val="115000"/>
+              </a:lnSpc>
+              <a:spcAft>
+                <a:spcPts val="482"/>
+              </a:spcAft>
+            </a:pPr>
+            <a:r>
+              <a:rPr b="1" lang="en-US" sz="1700" spc="-1" strike="noStrike">
+                <a:solidFill>
+                  <a:srgbClr val="46d4c4"/>
+                </a:solidFill>
+                <a:latin typeface="Arial"/>
+              </a:rPr>
+              <a:t>cat /dev/virtual_board</a:t>
+            </a:r>
+            <a:endParaRPr b="0" lang="en-US" sz="1700" spc="-1" strike="noStrike">
+              <a:solidFill>
+                <a:srgbClr val="ffffff"/>
+              </a:solidFill>
+              <a:latin typeface="Arial"/>
+            </a:endParaRPr>
+          </a:p>
+        </p:txBody>
+      </p:sp>
+      <p:sp>
+        <p:nvSpPr>
+          <p:cNvPr id="274" name=""/>
+          <p:cNvSpPr txBox="1"/>
+          <p:nvPr/>
+        </p:nvSpPr>
+        <p:spPr>
+          <a:xfrm>
+            <a:off x="576000" y="3654000"/>
+            <a:ext cx="5148000" cy="1656000"/>
+          </a:xfrm>
+          <a:prstGeom prst="rect">
+            <a:avLst/>
+          </a:prstGeom>
+          <a:noFill/>
+          <a:ln w="0">
+            <a:noFill/>
+          </a:ln>
+        </p:spPr>
+        <p:txBody>
+          <a:bodyPr lIns="90000" rIns="90000" tIns="45000" bIns="45000" anchor="t">
+            <a:noAutofit/>
+          </a:bodyPr>
+          <a:p>
+            <a:pPr>
+              <a:lnSpc>
+                <a:spcPct val="115000"/>
+              </a:lnSpc>
+              <a:spcAft>
+                <a:spcPts val="482"/>
+              </a:spcAft>
+            </a:pPr>
+            <a:r>
+              <a:rPr b="0" lang="en-US" sz="1600" spc="-1" strike="noStrike">
+                <a:solidFill>
+                  <a:srgbClr val="e8eef5"/>
+                </a:solidFill>
+                <a:latin typeface="Courier New"/>
+              </a:rPr>
+              <a:t>Новый читатель: пустой FIFO</a:t>
+            </a:r>
+            <a:endParaRPr b="0" lang="en-US" sz="1600" spc="-1" strike="noStrike">
+              <a:solidFill>
+                <a:srgbClr val="ffffff"/>
+              </a:solidFill>
+              <a:latin typeface="Arial"/>
+            </a:endParaRPr>
+          </a:p>
+          <a:p>
+            <a:pPr>
+              <a:lnSpc>
+                <a:spcPct val="115000"/>
+              </a:lnSpc>
+              <a:spcAft>
+                <a:spcPts val="482"/>
+              </a:spcAft>
+            </a:pPr>
+            <a:r>
+              <a:rPr b="0" lang="en-US" sz="1600" spc="-1" strike="noStrike">
+                <a:solidFill>
+                  <a:srgbClr val="e8eef5"/>
+                </a:solidFill>
+                <a:latin typeface="Courier New"/>
+              </a:rPr>
+              <a:t>read ждёт новое событие</a:t>
+            </a:r>
+            <a:endParaRPr b="0" lang="en-US" sz="1600" spc="-1" strike="noStrike">
+              <a:solidFill>
+                <a:srgbClr val="ffffff"/>
+              </a:solidFill>
+              <a:latin typeface="Arial"/>
+            </a:endParaRPr>
+          </a:p>
+          <a:p>
+            <a:pPr>
+              <a:lnSpc>
+                <a:spcPct val="115000"/>
+              </a:lnSpc>
+              <a:spcAft>
+                <a:spcPts val="482"/>
+              </a:spcAft>
+            </a:pPr>
+            <a:r>
+              <a:rPr b="0" lang="en-US" sz="1600" spc="-1" strike="noStrike">
+                <a:solidFill>
+                  <a:srgbClr val="e8eef5"/>
+                </a:solidFill>
+                <a:latin typeface="Courier New"/>
+              </a:rPr>
+              <a:t>Событие → строка в терминале</a:t>
+            </a:r>
+            <a:endParaRPr b="0" lang="en-US" sz="1600" spc="-1" strike="noStrike">
+              <a:solidFill>
+                <a:srgbClr val="ffffff"/>
+              </a:solidFill>
+              <a:latin typeface="Arial"/>
+            </a:endParaRPr>
+          </a:p>
+          <a:p>
+            <a:pPr>
+              <a:lnSpc>
+                <a:spcPct val="115000"/>
+              </a:lnSpc>
+              <a:spcAft>
+                <a:spcPts val="482"/>
+              </a:spcAft>
+            </a:pPr>
+            <a:r>
+              <a:rPr b="0" lang="en-US" sz="1600" spc="-1" strike="noStrike">
+                <a:solidFill>
+                  <a:srgbClr val="e8eef5"/>
+                </a:solidFill>
+                <a:latin typeface="Courier New"/>
+              </a:rPr>
+              <a:t>Затем снова ожидание</a:t>
+            </a:r>
+            <a:endParaRPr b="0" lang="en-US" sz="1600" spc="-1" strike="noStrike">
+              <a:solidFill>
+                <a:srgbClr val="ffffff"/>
+              </a:solidFill>
+              <a:latin typeface="Arial"/>
+            </a:endParaRPr>
+          </a:p>
+        </p:txBody>
+      </p:sp>
+      <p:sp>
+        <p:nvSpPr>
+          <p:cNvPr id="275" name=""/>
+          <p:cNvSpPr/>
+          <p:nvPr/>
+        </p:nvSpPr>
+        <p:spPr>
+          <a:xfrm>
+            <a:off x="6156000" y="3204000"/>
+            <a:ext cx="5580000" cy="2160000"/>
+          </a:xfrm>
+          <a:prstGeom prst="rect">
+            <a:avLst/>
+          </a:prstGeom>
+          <a:solidFill>
+            <a:srgbClr val="203248"/>
+          </a:solidFill>
+          <a:ln w="0">
+            <a:noFill/>
+          </a:ln>
+        </p:spPr>
+        <p:txBody>
+          <a:bodyPr lIns="90000" rIns="90000" tIns="45000" bIns="45000" anchor="t">
+            <a:noAutofit/>
+          </a:bodyPr>
+          <a:p>
+            <a:endParaRPr b="0" lang="en-US" sz="1800" spc="-1" strike="noStrike">
+              <a:solidFill>
+                <a:srgbClr val="ffffff"/>
+              </a:solidFill>
+              <a:latin typeface="Arial"/>
+            </a:endParaRPr>
+          </a:p>
+        </p:txBody>
+      </p:sp>
+      <p:sp>
+        <p:nvSpPr>
+          <p:cNvPr id="276" name=""/>
+          <p:cNvSpPr txBox="1"/>
+          <p:nvPr/>
+        </p:nvSpPr>
+        <p:spPr>
+          <a:xfrm>
+            <a:off x="6300000" y="3312000"/>
+            <a:ext cx="5292000" cy="368640"/>
+          </a:xfrm>
+          <a:prstGeom prst="rect">
+            <a:avLst/>
+          </a:prstGeom>
+          <a:noFill/>
+          <a:ln w="0">
+            <a:noFill/>
+          </a:ln>
+        </p:spPr>
+        <p:txBody>
+          <a:bodyPr lIns="90000" rIns="90000" tIns="45000" bIns="45000" anchor="t">
+            <a:noAutofit/>
+          </a:bodyPr>
+          <a:p>
+            <a:pPr>
+              <a:lnSpc>
+                <a:spcPct val="115000"/>
+              </a:lnSpc>
+              <a:spcAft>
+                <a:spcPts val="482"/>
+              </a:spcAft>
+            </a:pPr>
+            <a:r>
+              <a:rPr b="1" lang="en-US" sz="1700" spc="-1" strike="noStrike">
+                <a:solidFill>
+                  <a:srgbClr val="46d4c4"/>
+                </a:solidFill>
+                <a:latin typeface="Arial"/>
+              </a:rPr>
+              <a:t>cat атрибута sysfs</a:t>
+            </a:r>
+            <a:endParaRPr b="0" lang="en-US" sz="1700" spc="-1" strike="noStrike">
+              <a:solidFill>
+                <a:srgbClr val="ffffff"/>
+              </a:solidFill>
+              <a:latin typeface="Arial"/>
+            </a:endParaRPr>
+          </a:p>
+        </p:txBody>
+      </p:sp>
+      <p:sp>
+        <p:nvSpPr>
+          <p:cNvPr id="277" name=""/>
+          <p:cNvSpPr txBox="1"/>
+          <p:nvPr/>
+        </p:nvSpPr>
+        <p:spPr>
+          <a:xfrm>
+            <a:off x="6300000" y="3654000"/>
+            <a:ext cx="5292000" cy="1656000"/>
+          </a:xfrm>
+          <a:prstGeom prst="rect">
+            <a:avLst/>
+          </a:prstGeom>
+          <a:noFill/>
+          <a:ln w="0">
+            <a:noFill/>
+          </a:ln>
+        </p:spPr>
+        <p:txBody>
+          <a:bodyPr lIns="90000" rIns="90000" tIns="45000" bIns="45000" anchor="t">
+            <a:noAutofit/>
+          </a:bodyPr>
+          <a:p>
+            <a:pPr>
+              <a:lnSpc>
+                <a:spcPct val="115000"/>
+              </a:lnSpc>
+              <a:spcAft>
+                <a:spcPts val="482"/>
+              </a:spcAft>
+            </a:pPr>
+            <a:r>
+              <a:rPr b="0" lang="en-US" sz="2100" spc="-1" strike="noStrike">
+                <a:solidFill>
+                  <a:srgbClr val="e8eef5"/>
+                </a:solidFill>
+                <a:latin typeface="Arial"/>
+              </a:rPr>
+              <a:t>Чтение вызывает *_show()</a:t>
+            </a:r>
+            <a:endParaRPr b="0" lang="en-US" sz="2100" spc="-1" strike="noStrike">
+              <a:solidFill>
+                <a:srgbClr val="ffffff"/>
+              </a:solidFill>
+              <a:latin typeface="Arial"/>
+            </a:endParaRPr>
+          </a:p>
+          <a:p>
+            <a:pPr>
+              <a:lnSpc>
+                <a:spcPct val="115000"/>
+              </a:lnSpc>
+              <a:spcAft>
+                <a:spcPts val="482"/>
+              </a:spcAft>
+            </a:pPr>
+            <a:r>
+              <a:rPr b="0" lang="en-US" sz="2100" spc="-1" strike="noStrike">
+                <a:solidFill>
+                  <a:srgbClr val="e8eef5"/>
+                </a:solidFill>
+                <a:latin typeface="Arial"/>
+              </a:rPr>
+              <a:t>Поле board.status под mutex</a:t>
+            </a:r>
+            <a:endParaRPr b="0" lang="en-US" sz="2100" spc="-1" strike="noStrike">
+              <a:solidFill>
+                <a:srgbClr val="ffffff"/>
+              </a:solidFill>
+              <a:latin typeface="Arial"/>
+            </a:endParaRPr>
+          </a:p>
+          <a:p>
+            <a:pPr>
+              <a:lnSpc>
+                <a:spcPct val="115000"/>
+              </a:lnSpc>
+              <a:spcAft>
+                <a:spcPts val="482"/>
+              </a:spcAft>
+            </a:pPr>
+            <a:r>
+              <a:rPr b="0" lang="en-US" sz="2100" spc="-1" strike="noStrike">
+                <a:solidFill>
+                  <a:srgbClr val="e8eef5"/>
+                </a:solidFill>
+                <a:latin typeface="Arial"/>
+              </a:rPr>
+              <a:t>sysfs_emit → текущее значение</a:t>
+            </a:r>
+            <a:endParaRPr b="0" lang="en-US" sz="2100" spc="-1" strike="noStrike">
+              <a:solidFill>
+                <a:srgbClr val="ffffff"/>
+              </a:solidFill>
+              <a:latin typeface="Arial"/>
+            </a:endParaRPr>
+          </a:p>
+          <a:p>
+            <a:pPr>
+              <a:lnSpc>
+                <a:spcPct val="115000"/>
+              </a:lnSpc>
+              <a:spcAft>
+                <a:spcPts val="482"/>
+              </a:spcAft>
+            </a:pPr>
+            <a:r>
+              <a:rPr b="0" lang="en-US" sz="2100" spc="-1" strike="noStrike">
+                <a:solidFill>
+                  <a:srgbClr val="e8eef5"/>
+                </a:solidFill>
+                <a:latin typeface="Arial"/>
+              </a:rPr>
+              <a:t>cat выводит его и завершается</a:t>
+            </a:r>
+            <a:endParaRPr b="0" lang="en-US" sz="2100" spc="-1" strike="noStrike">
+              <a:solidFill>
+                <a:srgbClr val="ffffff"/>
+              </a:solidFill>
+              <a:latin typeface="Arial"/>
+            </a:endParaRPr>
+          </a:p>
+        </p:txBody>
+      </p:sp>
+      <p:sp>
+        <p:nvSpPr>
+          <p:cNvPr id="278" name=""/>
+          <p:cNvSpPr txBox="1"/>
+          <p:nvPr/>
+        </p:nvSpPr>
+        <p:spPr>
+          <a:xfrm>
+            <a:off x="432000" y="5634000"/>
+            <a:ext cx="11160000" cy="708120"/>
+          </a:xfrm>
+          <a:prstGeom prst="rect">
+            <a:avLst/>
+          </a:prstGeom>
+          <a:noFill/>
+          <a:ln w="0">
+            <a:noFill/>
+          </a:ln>
+        </p:spPr>
+        <p:txBody>
+          <a:bodyPr lIns="90000" rIns="90000" tIns="45000" bIns="45000" anchor="t">
+            <a:noAutofit/>
+          </a:bodyPr>
+          <a:p>
+            <a:pPr>
+              <a:lnSpc>
+                <a:spcPct val="115000"/>
+              </a:lnSpc>
+              <a:spcAft>
+                <a:spcPts val="482"/>
+              </a:spcAft>
+            </a:pPr>
+            <a:r>
+              <a:rPr b="0" lang="en-US" sz="1700" spc="-1" strike="noStrike">
+                <a:solidFill>
+                  <a:srgbClr val="ffd080"/>
+                </a:solidFill>
+                <a:latin typeface="Arial"/>
+              </a:rPr>
+              <a:t>GET_STATUS через ioctl тоже сразу возвращает текущее состояние.</a:t>
+            </a:r>
+            <a:endParaRPr b="0" lang="en-US" sz="1700" spc="-1" strike="noStrike">
+              <a:solidFill>
+                <a:srgbClr val="ffffff"/>
+              </a:solidFill>
+              <a:latin typeface="Arial"/>
+            </a:endParaRPr>
+          </a:p>
+          <a:p>
+            <a:pPr>
+              <a:lnSpc>
+                <a:spcPct val="115000"/>
+              </a:lnSpc>
+              <a:spcAft>
+                <a:spcPts val="482"/>
+              </a:spcAft>
+            </a:pPr>
+            <a:r>
+              <a:rPr b="0" lang="en-US" sz="1700" spc="-1" strike="noStrike">
+                <a:solidFill>
+                  <a:srgbClr val="ffd080"/>
+                </a:solidFill>
+                <a:latin typeface="Arial"/>
+              </a:rPr>
+              <a:t>Начальный снимок в FIFO не добавляется. Это контракт нашего драйвера.</a:t>
+            </a:r>
+            <a:endParaRPr b="0" lang="en-US" sz="1700" spc="-1" strike="noStrike">
+              <a:solidFill>
+                <a:srgbClr val="ffffff"/>
+              </a:solidFill>
+              <a:latin typeface="Arial"/>
+            </a:endParaRPr>
+          </a:p>
+        </p:txBody>
+      </p:sp>
+    </p:spTree>
+  </p:cSld>
+  <mc:AlternateContent>
+    <mc:Choice Requires="p14">
+      <p:transition spd="slow" p14:dur="2000"/>
+    </mc:Choice>
+    <mc:Fallback>
+      <p:transition spd="slow"/>
+    </mc:Fallback>
+  </mc:AlternateContent>
+</p:sld>
+</file>
+
+<file path=ppt/slides/slide15.xml><?xml version="1.0" encoding="utf-8"?>
+<p:sld xmlns:a="http://schemas.openxmlformats.org/drawingml/2006/main" xmlns:p="http://schemas.openxmlformats.org/presentationml/2006/main" xmlns:r="http://schemas.openxmlformats.org/officeDocument/2006/relationships" xmlns:p14="http://schemas.microsoft.com/office/powerpoint/2010/main" xmlns:p15="http://schemas.microsoft.com/office/powerpoint/2012/main" xmlns:mc="http://schemas.openxmlformats.org/markup-compatibility/2006">
+  <p:cSld>
+    <p:bg>
+      <p:bgPr>
+        <a:solidFill>
+          <a:srgbClr val="101d2d"/>
+        </a:solidFill>
+      </p:bgPr>
+    </p:bg>
+    <p:spTree>
+      <p:nvGrpSpPr>
+        <p:cNvPr id="1" name=""/>
+        <p:cNvGrpSpPr/>
+        <p:nvPr/>
+      </p:nvGrpSpPr>
+      <p:grpSpPr>
+        <a:xfrm>
+          <a:off x="0" y="0"/>
+          <a:ext cx="0" cy="0"/>
+          <a:chOff x="0" y="0"/>
+          <a:chExt cx="0" cy="0"/>
+        </a:xfrm>
+      </p:grpSpPr>
+      <p:sp>
+        <p:nvSpPr>
+          <p:cNvPr id="279" name=""/>
+          <p:cNvSpPr txBox="1"/>
+          <p:nvPr/>
+        </p:nvSpPr>
+        <p:spPr>
+          <a:xfrm>
+            <a:off x="432000" y="162000"/>
+            <a:ext cx="11160000" cy="286560"/>
+          </a:xfrm>
+          <a:prstGeom prst="rect">
+            <a:avLst/>
+          </a:prstGeom>
+          <a:noFill/>
+          <a:ln w="0">
+            <a:noFill/>
+          </a:ln>
+        </p:spPr>
+        <p:txBody>
+          <a:bodyPr lIns="90000" rIns="90000" tIns="45000" bIns="45000" anchor="t">
+            <a:noAutofit/>
+          </a:bodyPr>
+          <a:p>
+            <a:pPr>
+              <a:lnSpc>
+                <a:spcPct val="115000"/>
+              </a:lnSpc>
+              <a:spcAft>
+                <a:spcPts val="482"/>
+              </a:spcAft>
+            </a:pPr>
+            <a:r>
+              <a:rPr b="1" lang="en-US" sz="1200" spc="-1" strike="noStrike">
+                <a:solidFill>
+                  <a:srgbClr val="46d4c4"/>
+                </a:solidFill>
+                <a:latin typeface="Arial"/>
+              </a:rPr>
+              <a:t>VIRTUAL BOARD / АНДРЕЙ ЮНИН / OTUS · LINUX KERNEL</a:t>
+            </a:r>
+            <a:endParaRPr b="0" lang="en-US" sz="1200" spc="-1" strike="noStrike">
+              <a:solidFill>
+                <a:srgbClr val="ffffff"/>
+              </a:solidFill>
+              <a:latin typeface="Arial"/>
+            </a:endParaRPr>
+          </a:p>
+        </p:txBody>
+      </p:sp>
+      <p:sp>
+        <p:nvSpPr>
+          <p:cNvPr id="280" name=""/>
+          <p:cNvSpPr txBox="1"/>
+          <p:nvPr/>
+        </p:nvSpPr>
+        <p:spPr>
+          <a:xfrm>
+            <a:off x="432000" y="486000"/>
+            <a:ext cx="11304000" cy="612000"/>
+          </a:xfrm>
+          <a:prstGeom prst="rect">
+            <a:avLst/>
+          </a:prstGeom>
+          <a:noFill/>
+          <a:ln w="0">
+            <a:noFill/>
+          </a:ln>
+        </p:spPr>
+        <p:txBody>
+          <a:bodyPr lIns="90000" rIns="90000" tIns="45000" bIns="45000" anchor="t">
+            <a:noAutofit/>
+          </a:bodyPr>
+          <a:p>
+            <a:pPr>
+              <a:lnSpc>
+                <a:spcPct val="115000"/>
+              </a:lnSpc>
+              <a:spcAft>
+                <a:spcPts val="482"/>
+              </a:spcAft>
+            </a:pPr>
+            <a:r>
+              <a:rPr b="1" lang="en-US" sz="3000" spc="-1" strike="noStrike">
+                <a:solidFill>
+                  <a:srgbClr val="ffffff"/>
+                </a:solidFill>
+                <a:latin typeface="Arial"/>
+              </a:rPr>
+              <a:t>Procfs: сводка платы и клиентов</a:t>
+            </a:r>
+            <a:endParaRPr b="0" lang="en-US" sz="3000" spc="-1" strike="noStrike">
+              <a:solidFill>
+                <a:srgbClr val="ffffff"/>
+              </a:solidFill>
+              <a:latin typeface="Arial"/>
+            </a:endParaRPr>
+          </a:p>
+        </p:txBody>
+      </p:sp>
+      <p:sp>
+        <p:nvSpPr>
+          <p:cNvPr id="281" name=""/>
+          <p:cNvSpPr txBox="1"/>
+          <p:nvPr/>
+        </p:nvSpPr>
+        <p:spPr>
+          <a:xfrm>
+            <a:off x="432000" y="6498000"/>
+            <a:ext cx="10440000" cy="349920"/>
+          </a:xfrm>
+          <a:prstGeom prst="rect">
+            <a:avLst/>
+          </a:prstGeom>
+          <a:noFill/>
+          <a:ln w="0">
+            <a:noFill/>
+          </a:ln>
+        </p:spPr>
+        <p:txBody>
+          <a:bodyPr lIns="90000" rIns="90000" tIns="45000" bIns="45000" anchor="t">
+            <a:noAutofit/>
+          </a:bodyPr>
+          <a:p>
+            <a:pPr>
+              <a:lnSpc>
+                <a:spcPct val="115000"/>
+              </a:lnSpc>
+              <a:spcAft>
+                <a:spcPts val="482"/>
+              </a:spcAft>
+            </a:pPr>
+            <a:r>
+              <a:rPr b="0" lang="en-US" sz="1600" spc="-1" strike="noStrike">
+                <a:solidFill>
+                  <a:srgbClr val="aebccd"/>
+                </a:solidFill>
+                <a:latin typeface="Arial"/>
+              </a:rPr>
+              <a:t>Источник: проверка пользователя 22.09; подробности — REPORT</a:t>
+            </a:r>
+            <a:endParaRPr b="0" lang="en-US" sz="1600" spc="-1" strike="noStrike">
+              <a:solidFill>
+                <a:srgbClr val="ffffff"/>
+              </a:solidFill>
+              <a:latin typeface="Arial"/>
+            </a:endParaRPr>
+          </a:p>
+        </p:txBody>
+      </p:sp>
+      <p:sp>
+        <p:nvSpPr>
+          <p:cNvPr id="282" name=""/>
+          <p:cNvSpPr txBox="1"/>
+          <p:nvPr/>
+        </p:nvSpPr>
+        <p:spPr>
+          <a:xfrm>
+            <a:off x="11160000" y="6498000"/>
+            <a:ext cx="540000" cy="349920"/>
+          </a:xfrm>
+          <a:prstGeom prst="rect">
+            <a:avLst/>
+          </a:prstGeom>
+          <a:noFill/>
+          <a:ln w="0">
+            <a:noFill/>
+          </a:ln>
+        </p:spPr>
+        <p:txBody>
+          <a:bodyPr lIns="90000" rIns="90000" tIns="45000" bIns="45000" anchor="t">
+            <a:noAutofit/>
+          </a:bodyPr>
+          <a:p>
+            <a:pPr>
+              <a:lnSpc>
+                <a:spcPct val="115000"/>
+              </a:lnSpc>
+              <a:spcAft>
+                <a:spcPts val="482"/>
+              </a:spcAft>
+            </a:pPr>
+            <a:r>
+              <a:rPr b="0" lang="en-US" sz="1600" spc="-1" strike="noStrike">
+                <a:solidFill>
+                  <a:srgbClr val="aebccd"/>
+                </a:solidFill>
+                <a:latin typeface="Arial"/>
+              </a:rPr>
+              <a:t>15</a:t>
+            </a:r>
+            <a:endParaRPr b="0" lang="en-US" sz="1600" spc="-1" strike="noStrike">
+              <a:solidFill>
+                <a:srgbClr val="ffffff"/>
+              </a:solidFill>
+              <a:latin typeface="Arial"/>
+            </a:endParaRPr>
+          </a:p>
+        </p:txBody>
+      </p:sp>
+      <p:sp>
+        <p:nvSpPr>
+          <p:cNvPr id="283" name=""/>
+          <p:cNvSpPr/>
+          <p:nvPr/>
+        </p:nvSpPr>
+        <p:spPr>
+          <a:xfrm>
+            <a:off x="432000" y="1332000"/>
+            <a:ext cx="11304000" cy="1584000"/>
+          </a:xfrm>
+          <a:prstGeom prst="rect">
+            <a:avLst/>
+          </a:prstGeom>
+          <a:solidFill>
+            <a:srgbClr val="173e43"/>
+          </a:solidFill>
+          <a:ln w="0">
+            <a:noFill/>
+          </a:ln>
+        </p:spPr>
+        <p:txBody>
+          <a:bodyPr lIns="90000" rIns="90000" tIns="45000" bIns="45000" anchor="t">
+            <a:noAutofit/>
+          </a:bodyPr>
+          <a:p>
+            <a:endParaRPr b="0" lang="en-US" sz="1800" spc="-1" strike="noStrike">
+              <a:solidFill>
+                <a:srgbClr val="ffffff"/>
+              </a:solidFill>
+              <a:latin typeface="Arial"/>
+            </a:endParaRPr>
+          </a:p>
+        </p:txBody>
+      </p:sp>
+      <p:sp>
+        <p:nvSpPr>
+          <p:cNvPr id="284" name=""/>
+          <p:cNvSpPr txBox="1"/>
+          <p:nvPr/>
+        </p:nvSpPr>
+        <p:spPr>
+          <a:xfrm>
+            <a:off x="576000" y="1440000"/>
+            <a:ext cx="11016000" cy="368640"/>
+          </a:xfrm>
+          <a:prstGeom prst="rect">
+            <a:avLst/>
+          </a:prstGeom>
+          <a:noFill/>
+          <a:ln w="0">
+            <a:noFill/>
+          </a:ln>
+        </p:spPr>
+        <p:txBody>
+          <a:bodyPr lIns="90000" rIns="90000" tIns="45000" bIns="45000" anchor="t">
+            <a:noAutofit/>
+          </a:bodyPr>
+          <a:p>
+            <a:pPr>
+              <a:lnSpc>
+                <a:spcPct val="115000"/>
+              </a:lnSpc>
+              <a:spcAft>
+                <a:spcPts val="482"/>
+              </a:spcAft>
+            </a:pPr>
+            <a:r>
+              <a:rPr b="1" lang="en-US" sz="1700" spc="-1" strike="noStrike">
+                <a:solidFill>
+                  <a:srgbClr val="46d4c4"/>
+                </a:solidFill>
+                <a:latin typeface="Arial"/>
+              </a:rPr>
+              <a:t>cat /proc/virtual_board → СНИМОК ПРИ ОТКРЫТИИ</a:t>
+            </a:r>
+            <a:endParaRPr b="0" lang="en-US" sz="1700" spc="-1" strike="noStrike">
+              <a:solidFill>
+                <a:srgbClr val="ffffff"/>
+              </a:solidFill>
+              <a:latin typeface="Arial"/>
+            </a:endParaRPr>
+          </a:p>
+        </p:txBody>
+      </p:sp>
+      <p:sp>
+        <p:nvSpPr>
+          <p:cNvPr id="285" name=""/>
+          <p:cNvSpPr txBox="1"/>
+          <p:nvPr/>
+        </p:nvSpPr>
+        <p:spPr>
+          <a:xfrm>
+            <a:off x="576000" y="1782000"/>
+            <a:ext cx="11016000" cy="1080000"/>
+          </a:xfrm>
+          <a:prstGeom prst="rect">
+            <a:avLst/>
+          </a:prstGeom>
+          <a:noFill/>
+          <a:ln w="0">
+            <a:noFill/>
+          </a:ln>
+        </p:spPr>
+        <p:txBody>
+          <a:bodyPr lIns="90000" rIns="90000" tIns="45000" bIns="45000" anchor="t">
+            <a:noAutofit/>
+          </a:bodyPr>
+          <a:p>
+            <a:endParaRPr b="0" lang="en-US" sz="1800" spc="-1" strike="noStrike">
+              <a:solidFill>
+                <a:srgbClr val="ffffff"/>
+              </a:solidFill>
+              <a:latin typeface="Arial"/>
+            </a:endParaRPr>
+          </a:p>
+        </p:txBody>
+      </p:sp>
+      <p:sp>
+        <p:nvSpPr>
+          <p:cNvPr id="286" name=""/>
+          <p:cNvSpPr txBox="1"/>
+          <p:nvPr/>
+        </p:nvSpPr>
+        <p:spPr>
+          <a:xfrm>
+            <a:off x="648000" y="1800000"/>
+            <a:ext cx="10800000" cy="813240"/>
+          </a:xfrm>
+          <a:prstGeom prst="rect">
+            <a:avLst/>
+          </a:prstGeom>
+          <a:noFill/>
+          <a:ln w="0">
+            <a:noFill/>
+          </a:ln>
+        </p:spPr>
+        <p:txBody>
+          <a:bodyPr lIns="90000" rIns="90000" tIns="45000" bIns="45000" anchor="t">
+            <a:noAutofit/>
+          </a:bodyPr>
+          <a:p>
+            <a:pPr>
+              <a:lnSpc>
+                <a:spcPct val="115000"/>
+              </a:lnSpc>
+              <a:spcAft>
+                <a:spcPts val="482"/>
+              </a:spcAft>
+            </a:pPr>
+            <a:r>
+              <a:rPr b="0" lang="en-US" sz="2000" spc="-1" strike="noStrike">
+                <a:solidFill>
+                  <a:srgbClr val="e8eef5"/>
+                </a:solidFill>
+                <a:latin typeface="Courier New"/>
+              </a:rPr>
+              <a:t>Плата: temp=250, low=100, high=700, period_ms=100</a:t>
+            </a:r>
+            <a:endParaRPr b="0" lang="en-US" sz="2000" spc="-1" strike="noStrike">
+              <a:solidFill>
+                <a:srgbClr val="ffffff"/>
+              </a:solidFill>
+              <a:latin typeface="Arial"/>
+            </a:endParaRPr>
+          </a:p>
+          <a:p>
+            <a:pPr>
+              <a:lnSpc>
+                <a:spcPct val="115000"/>
+              </a:lnSpc>
+              <a:spcAft>
+                <a:spcPts val="482"/>
+              </a:spcAft>
+            </a:pPr>
+            <a:r>
+              <a:rPr b="0" lang="en-US" sz="2000" spc="-1" strike="noStrike">
+                <a:solidFill>
+                  <a:srgbClr val="e8eef5"/>
+                </a:solidFill>
+                <a:latin typeface="Courier New"/>
+              </a:rPr>
+              <a:t>После start: state=running, temp_status=normal</a:t>
+            </a:r>
+            <a:endParaRPr b="0" lang="en-US" sz="2000" spc="-1" strike="noStrike">
+              <a:solidFill>
+                <a:srgbClr val="ffffff"/>
+              </a:solidFill>
+              <a:latin typeface="Arial"/>
+            </a:endParaRPr>
+          </a:p>
+        </p:txBody>
+      </p:sp>
+      <p:sp>
+        <p:nvSpPr>
+          <p:cNvPr id="287" name=""/>
+          <p:cNvSpPr txBox="1"/>
+          <p:nvPr/>
+        </p:nvSpPr>
+        <p:spPr>
+          <a:xfrm>
+            <a:off x="648000" y="2592000"/>
+            <a:ext cx="10800000" cy="349920"/>
+          </a:xfrm>
+          <a:prstGeom prst="rect">
+            <a:avLst/>
+          </a:prstGeom>
+          <a:noFill/>
+          <a:ln w="0">
+            <a:noFill/>
+          </a:ln>
+        </p:spPr>
+        <p:txBody>
+          <a:bodyPr lIns="90000" rIns="90000" tIns="45000" bIns="45000" anchor="t">
+            <a:noAutofit/>
+          </a:bodyPr>
+          <a:p>
+            <a:pPr>
+              <a:lnSpc>
+                <a:spcPct val="115000"/>
+              </a:lnSpc>
+              <a:spcAft>
+                <a:spcPts val="482"/>
+              </a:spcAft>
+            </a:pPr>
+            <a:r>
+              <a:rPr b="0" lang="en-US" sz="1600" spc="-1" strike="noStrike">
+                <a:solidFill>
+                  <a:srgbClr val="aebccd"/>
+                </a:solidFill>
+                <a:latin typeface="Arial"/>
+              </a:rPr>
+              <a:t>open → сформировать текст; read → части текста → EOF; release → освободить.</a:t>
+            </a:r>
+            <a:endParaRPr b="0" lang="en-US" sz="1600" spc="-1" strike="noStrike">
+              <a:solidFill>
+                <a:srgbClr val="ffffff"/>
+              </a:solidFill>
+              <a:latin typeface="Arial"/>
+            </a:endParaRPr>
+          </a:p>
+        </p:txBody>
+      </p:sp>
+      <p:sp>
+        <p:nvSpPr>
+          <p:cNvPr id="288" name=""/>
+          <p:cNvSpPr/>
+          <p:nvPr/>
+        </p:nvSpPr>
+        <p:spPr>
+          <a:xfrm>
+            <a:off x="432000" y="3204000"/>
+            <a:ext cx="5436000" cy="2160000"/>
+          </a:xfrm>
+          <a:prstGeom prst="rect">
+            <a:avLst/>
+          </a:prstGeom>
+          <a:solidFill>
+            <a:srgbClr val="203248"/>
+          </a:solidFill>
+          <a:ln w="0">
+            <a:noFill/>
+          </a:ln>
+        </p:spPr>
+        <p:txBody>
+          <a:bodyPr lIns="90000" rIns="90000" tIns="45000" bIns="45000" anchor="t">
+            <a:noAutofit/>
+          </a:bodyPr>
+          <a:p>
+            <a:endParaRPr b="0" lang="en-US" sz="1800" spc="-1" strike="noStrike">
+              <a:solidFill>
+                <a:srgbClr val="ffffff"/>
+              </a:solidFill>
+              <a:latin typeface="Arial"/>
+            </a:endParaRPr>
+          </a:p>
+        </p:txBody>
+      </p:sp>
+      <p:sp>
+        <p:nvSpPr>
+          <p:cNvPr id="289" name=""/>
+          <p:cNvSpPr txBox="1"/>
+          <p:nvPr/>
+        </p:nvSpPr>
+        <p:spPr>
+          <a:xfrm>
+            <a:off x="576000" y="3312000"/>
+            <a:ext cx="5148000" cy="368640"/>
+          </a:xfrm>
+          <a:prstGeom prst="rect">
+            <a:avLst/>
+          </a:prstGeom>
+          <a:noFill/>
+          <a:ln w="0">
+            <a:noFill/>
+          </a:ln>
+        </p:spPr>
+        <p:txBody>
+          <a:bodyPr lIns="90000" rIns="90000" tIns="45000" bIns="45000" anchor="t">
+            <a:noAutofit/>
+          </a:bodyPr>
+          <a:p>
+            <a:pPr>
+              <a:lnSpc>
+                <a:spcPct val="115000"/>
+              </a:lnSpc>
+              <a:spcAft>
+                <a:spcPts val="482"/>
+              </a:spcAft>
+            </a:pPr>
+            <a:r>
+              <a:rPr b="1" lang="en-US" sz="1700" spc="-1" strike="noStrike">
+                <a:solidFill>
+                  <a:srgbClr val="46d4c4"/>
+                </a:solidFill>
+                <a:latin typeface="Arial"/>
+              </a:rPr>
+              <a:t>ЧИТАТЕЛЬ /dev ОТКРЫТ</a:t>
+            </a:r>
+            <a:endParaRPr b="0" lang="en-US" sz="1700" spc="-1" strike="noStrike">
+              <a:solidFill>
+                <a:srgbClr val="ffffff"/>
+              </a:solidFill>
+              <a:latin typeface="Arial"/>
+            </a:endParaRPr>
+          </a:p>
+        </p:txBody>
+      </p:sp>
+      <p:sp>
+        <p:nvSpPr>
+          <p:cNvPr id="290" name=""/>
+          <p:cNvSpPr txBox="1"/>
+          <p:nvPr/>
+        </p:nvSpPr>
+        <p:spPr>
+          <a:xfrm>
+            <a:off x="576000" y="3654000"/>
+            <a:ext cx="5148000" cy="1656000"/>
+          </a:xfrm>
+          <a:prstGeom prst="rect">
+            <a:avLst/>
+          </a:prstGeom>
+          <a:noFill/>
+          <a:ln w="0">
+            <a:noFill/>
+          </a:ln>
+        </p:spPr>
+        <p:txBody>
+          <a:bodyPr lIns="90000" rIns="90000" tIns="45000" bIns="45000" anchor="t">
+            <a:noAutofit/>
+          </a:bodyPr>
+          <a:p>
+            <a:pPr>
+              <a:lnSpc>
+                <a:spcPct val="115000"/>
+              </a:lnSpc>
+              <a:spcAft>
+                <a:spcPts val="482"/>
+              </a:spcAft>
+            </a:pPr>
+            <a:r>
+              <a:rPr b="0" lang="en-US" sz="1600" spc="-1" strike="noStrike">
+                <a:solidFill>
+                  <a:srgbClr val="e8eef5"/>
+                </a:solidFill>
+                <a:latin typeface="Courier New"/>
+              </a:rPr>
+              <a:t>clients=1</a:t>
+            </a:r>
+            <a:endParaRPr b="0" lang="en-US" sz="1600" spc="-1" strike="noStrike">
+              <a:solidFill>
+                <a:srgbClr val="ffffff"/>
+              </a:solidFill>
+              <a:latin typeface="Arial"/>
+            </a:endParaRPr>
+          </a:p>
+          <a:p>
+            <a:pPr>
+              <a:lnSpc>
+                <a:spcPct val="115000"/>
+              </a:lnSpc>
+              <a:spcAft>
+                <a:spcPts val="482"/>
+              </a:spcAft>
+            </a:pPr>
+            <a:r>
+              <a:rPr b="0" lang="en-US" sz="1600" spc="-1" strike="noStrike">
+                <a:solidFill>
+                  <a:srgbClr val="e8eef5"/>
+                </a:solidFill>
+                <a:latin typeface="Courier New"/>
+              </a:rPr>
+              <a:t>pid=141943 opens=1</a:t>
+            </a:r>
+            <a:endParaRPr b="0" lang="en-US" sz="1600" spc="-1" strike="noStrike">
+              <a:solidFill>
+                <a:srgbClr val="ffffff"/>
+              </a:solidFill>
+              <a:latin typeface="Arial"/>
+            </a:endParaRPr>
+          </a:p>
+          <a:p>
+            <a:pPr>
+              <a:lnSpc>
+                <a:spcPct val="115000"/>
+              </a:lnSpc>
+              <a:spcAft>
+                <a:spcPts val="482"/>
+              </a:spcAft>
+            </a:pPr>
+            <a:r>
+              <a:rPr b="0" lang="en-US" sz="1600" spc="-1" strike="noStrike">
+                <a:solidFill>
+                  <a:srgbClr val="e8eef5"/>
+                </a:solidFill>
+                <a:latin typeface="Courier New"/>
+              </a:rPr>
+              <a:t>readers=1 lost_events=0</a:t>
+            </a:r>
+            <a:endParaRPr b="0" lang="en-US" sz="1600" spc="-1" strike="noStrike">
+              <a:solidFill>
+                <a:srgbClr val="ffffff"/>
+              </a:solidFill>
+              <a:latin typeface="Arial"/>
+            </a:endParaRPr>
+          </a:p>
+          <a:p>
+            <a:pPr>
+              <a:lnSpc>
+                <a:spcPct val="115000"/>
+              </a:lnSpc>
+              <a:spcAft>
+                <a:spcPts val="482"/>
+              </a:spcAft>
+            </a:pPr>
+            <a:r>
+              <a:rPr b="0" lang="en-US" sz="1600" spc="-1" strike="noStrike">
+                <a:solidFill>
+                  <a:srgbClr val="e8eef5"/>
+                </a:solidFill>
+                <a:latin typeface="Courier New"/>
+              </a:rPr>
+              <a:t>Событие started доставлено</a:t>
+            </a:r>
+            <a:endParaRPr b="0" lang="en-US" sz="1600" spc="-1" strike="noStrike">
+              <a:solidFill>
+                <a:srgbClr val="ffffff"/>
+              </a:solidFill>
+              <a:latin typeface="Arial"/>
+            </a:endParaRPr>
+          </a:p>
+        </p:txBody>
+      </p:sp>
+      <p:sp>
+        <p:nvSpPr>
+          <p:cNvPr id="291" name=""/>
+          <p:cNvSpPr/>
+          <p:nvPr/>
+        </p:nvSpPr>
+        <p:spPr>
+          <a:xfrm>
+            <a:off x="6156000" y="3204000"/>
+            <a:ext cx="5580000" cy="2160000"/>
+          </a:xfrm>
+          <a:prstGeom prst="rect">
+            <a:avLst/>
+          </a:prstGeom>
+          <a:solidFill>
+            <a:srgbClr val="203248"/>
+          </a:solidFill>
+          <a:ln w="0">
+            <a:noFill/>
+          </a:ln>
+        </p:spPr>
+        <p:txBody>
+          <a:bodyPr lIns="90000" rIns="90000" tIns="45000" bIns="45000" anchor="t">
+            <a:noAutofit/>
+          </a:bodyPr>
+          <a:p>
+            <a:endParaRPr b="0" lang="en-US" sz="1800" spc="-1" strike="noStrike">
+              <a:solidFill>
+                <a:srgbClr val="ffffff"/>
+              </a:solidFill>
+              <a:latin typeface="Arial"/>
+            </a:endParaRPr>
+          </a:p>
+        </p:txBody>
+      </p:sp>
+      <p:sp>
+        <p:nvSpPr>
+          <p:cNvPr id="292" name=""/>
+          <p:cNvSpPr txBox="1"/>
+          <p:nvPr/>
+        </p:nvSpPr>
+        <p:spPr>
+          <a:xfrm>
+            <a:off x="6300000" y="3312000"/>
+            <a:ext cx="5292000" cy="368640"/>
+          </a:xfrm>
+          <a:prstGeom prst="rect">
+            <a:avLst/>
+          </a:prstGeom>
+          <a:noFill/>
+          <a:ln w="0">
+            <a:noFill/>
+          </a:ln>
+        </p:spPr>
+        <p:txBody>
+          <a:bodyPr lIns="90000" rIns="90000" tIns="45000" bIns="45000" anchor="t">
+            <a:noAutofit/>
+          </a:bodyPr>
+          <a:p>
+            <a:pPr>
+              <a:lnSpc>
+                <a:spcPct val="115000"/>
+              </a:lnSpc>
+              <a:spcAft>
+                <a:spcPts val="482"/>
+              </a:spcAft>
+            </a:pPr>
+            <a:r>
+              <a:rPr b="1" lang="en-US" sz="1700" spc="-1" strike="noStrike">
+                <a:solidFill>
+                  <a:srgbClr val="46d4c4"/>
+                </a:solidFill>
+                <a:latin typeface="Arial"/>
+              </a:rPr>
+              <a:t>ЧИТАТЕЛЬ /dev ЗАКРЫТ</a:t>
+            </a:r>
+            <a:endParaRPr b="0" lang="en-US" sz="1700" spc="-1" strike="noStrike">
+              <a:solidFill>
+                <a:srgbClr val="ffffff"/>
+              </a:solidFill>
+              <a:latin typeface="Arial"/>
+            </a:endParaRPr>
+          </a:p>
+        </p:txBody>
+      </p:sp>
+      <p:sp>
+        <p:nvSpPr>
+          <p:cNvPr id="293" name=""/>
+          <p:cNvSpPr txBox="1"/>
+          <p:nvPr/>
+        </p:nvSpPr>
+        <p:spPr>
+          <a:xfrm>
+            <a:off x="6300000" y="3654000"/>
+            <a:ext cx="5292000" cy="1656000"/>
+          </a:xfrm>
+          <a:prstGeom prst="rect">
+            <a:avLst/>
+          </a:prstGeom>
+          <a:noFill/>
+          <a:ln w="0">
+            <a:noFill/>
+          </a:ln>
+        </p:spPr>
+        <p:txBody>
+          <a:bodyPr lIns="90000" rIns="90000" tIns="45000" bIns="45000" anchor="t">
+            <a:noAutofit/>
+          </a:bodyPr>
+          <a:p>
+            <a:pPr>
+              <a:lnSpc>
+                <a:spcPct val="115000"/>
+              </a:lnSpc>
+              <a:spcAft>
+                <a:spcPts val="482"/>
+              </a:spcAft>
+            </a:pPr>
+            <a:r>
+              <a:rPr b="0" lang="en-US" sz="2100" spc="-1" strike="noStrike">
+                <a:solidFill>
+                  <a:srgbClr val="e8eef5"/>
+                </a:solidFill>
+                <a:latin typeface="Arial"/>
+              </a:rPr>
+              <a:t>clients=0</a:t>
+            </a:r>
+            <a:endParaRPr b="0" lang="en-US" sz="2100" spc="-1" strike="noStrike">
+              <a:solidFill>
+                <a:srgbClr val="ffffff"/>
+              </a:solidFill>
+              <a:latin typeface="Arial"/>
+            </a:endParaRPr>
+          </a:p>
+          <a:p>
+            <a:pPr>
+              <a:lnSpc>
+                <a:spcPct val="115000"/>
+              </a:lnSpc>
+              <a:spcAft>
+                <a:spcPts val="482"/>
+              </a:spcAft>
+            </a:pPr>
+            <a:r>
+              <a:rPr b="0" lang="en-US" sz="2100" spc="-1" strike="noStrike">
+                <a:solidFill>
+                  <a:srgbClr val="e8eef5"/>
+                </a:solidFill>
+                <a:latin typeface="Arial"/>
+              </a:rPr>
+              <a:t>Строки pid больше нет</a:t>
+            </a:r>
+            <a:endParaRPr b="0" lang="en-US" sz="2100" spc="-1" strike="noStrike">
+              <a:solidFill>
+                <a:srgbClr val="ffffff"/>
+              </a:solidFill>
+              <a:latin typeface="Arial"/>
+            </a:endParaRPr>
+          </a:p>
+          <a:p>
+            <a:pPr>
+              <a:lnSpc>
+                <a:spcPct val="115000"/>
+              </a:lnSpc>
+              <a:spcAft>
+                <a:spcPts val="482"/>
+              </a:spcAft>
+            </a:pPr>
+            <a:r>
+              <a:rPr b="0" lang="en-US" sz="2100" spc="-1" strike="noStrike">
+                <a:solidFill>
+                  <a:srgbClr val="e8eef5"/>
+                </a:solidFill>
+                <a:latin typeface="Arial"/>
+              </a:rPr>
+              <a:t>Плата остаётся running</a:t>
+            </a:r>
+            <a:endParaRPr b="0" lang="en-US" sz="2100" spc="-1" strike="noStrike">
+              <a:solidFill>
+                <a:srgbClr val="ffffff"/>
+              </a:solidFill>
+              <a:latin typeface="Arial"/>
+            </a:endParaRPr>
+          </a:p>
+          <a:p>
+            <a:pPr>
+              <a:lnSpc>
+                <a:spcPct val="115000"/>
+              </a:lnSpc>
+              <a:spcAft>
+                <a:spcPts val="482"/>
+              </a:spcAft>
+            </a:pPr>
+            <a:r>
+              <a:rPr b="0" lang="en-US" sz="2100" spc="-1" strike="noStrike">
+                <a:solidFill>
+                  <a:srgbClr val="e8eef5"/>
+                </a:solidFill>
+                <a:latin typeface="Arial"/>
+              </a:rPr>
+              <a:t>Закрытие cat не вызывает stop</a:t>
+            </a:r>
+            <a:endParaRPr b="0" lang="en-US" sz="2100" spc="-1" strike="noStrike">
+              <a:solidFill>
+                <a:srgbClr val="ffffff"/>
+              </a:solidFill>
+              <a:latin typeface="Arial"/>
+            </a:endParaRPr>
+          </a:p>
+        </p:txBody>
+      </p:sp>
+      <p:sp>
+        <p:nvSpPr>
+          <p:cNvPr id="294" name=""/>
+          <p:cNvSpPr txBox="1"/>
+          <p:nvPr/>
+        </p:nvSpPr>
+        <p:spPr>
+          <a:xfrm>
+            <a:off x="432000" y="5634000"/>
+            <a:ext cx="11160000" cy="708120"/>
+          </a:xfrm>
+          <a:prstGeom prst="rect">
+            <a:avLst/>
+          </a:prstGeom>
+          <a:noFill/>
+          <a:ln w="0">
+            <a:noFill/>
+          </a:ln>
+        </p:spPr>
+        <p:txBody>
+          <a:bodyPr lIns="90000" rIns="90000" tIns="45000" bIns="45000" anchor="t">
+            <a:noAutofit/>
+          </a:bodyPr>
+          <a:p>
+            <a:pPr>
+              <a:lnSpc>
+                <a:spcPct val="115000"/>
+              </a:lnSpc>
+              <a:spcAft>
+                <a:spcPts val="482"/>
+              </a:spcAft>
+            </a:pPr>
+            <a:r>
+              <a:rPr b="0" lang="en-US" sz="1700" spc="-1" strike="noStrike">
+                <a:solidFill>
+                  <a:srgbClr val="ffd080"/>
+                </a:solidFill>
+                <a:latin typeface="Arial"/>
+              </a:rPr>
+              <a:t>После stop и unload: пути /proc, /dev и класс sysfs удалены.</a:t>
+            </a:r>
+            <a:endParaRPr b="0" lang="en-US" sz="1700" spc="-1" strike="noStrike">
+              <a:solidFill>
+                <a:srgbClr val="ffffff"/>
+              </a:solidFill>
+              <a:latin typeface="Arial"/>
+            </a:endParaRPr>
+          </a:p>
+          <a:p>
+            <a:pPr>
+              <a:lnSpc>
+                <a:spcPct val="115000"/>
+              </a:lnSpc>
+              <a:spcAft>
+                <a:spcPts val="482"/>
+              </a:spcAft>
+            </a:pPr>
+            <a:r>
+              <a:rPr b="0" lang="en-US" sz="1700" spc="-1" strike="noStrike">
+                <a:solidFill>
+                  <a:srgbClr val="ffd080"/>
+                </a:solidFill>
+                <a:latin typeface="Arial"/>
+              </a:rPr>
+              <a:t>Переполнение и чтение proc короткими порциями ещё не проверены.</a:t>
+            </a:r>
+            <a:endParaRPr b="0" lang="en-US" sz="1700" spc="-1" strike="noStrike">
+              <a:solidFill>
+                <a:srgbClr val="ffffff"/>
+              </a:solidFill>
+              <a:latin typeface="Arial"/>
+            </a:endParaRPr>
+          </a:p>
+        </p:txBody>
+      </p:sp>
+    </p:spTree>
+  </p:cSld>
+  <mc:AlternateContent>
+    <mc:Choice Requires="p14">
+      <p:transition spd="slow" p14:dur="2000"/>
+    </mc:Choice>
+    <mc:Fallback>
+      <p:transition spd="slow"/>
+    </mc:Fallback>
+  </mc:AlternateContent>
+</p:sld>
+</file>
+
+<file path=ppt/slides/slide16.xml><?xml version="1.0" encoding="utf-8"?>
+<p:sld xmlns:a="http://schemas.openxmlformats.org/drawingml/2006/main" xmlns:p="http://schemas.openxmlformats.org/presentationml/2006/main" xmlns:r="http://schemas.openxmlformats.org/officeDocument/2006/relationships" xmlns:p14="http://schemas.microsoft.com/office/powerpoint/2010/main" xmlns:p15="http://schemas.microsoft.com/office/powerpoint/2012/main" xmlns:mc="http://schemas.openxmlformats.org/markup-compatibility/2006">
+  <p:cSld>
+    <p:bg>
+      <p:bgPr>
+        <a:solidFill>
+          <a:srgbClr val="101d2d"/>
+        </a:solidFill>
+      </p:bgPr>
+    </p:bg>
+    <p:spTree>
+      <p:nvGrpSpPr>
+        <p:cNvPr id="1" name=""/>
+        <p:cNvGrpSpPr/>
+        <p:nvPr/>
+      </p:nvGrpSpPr>
+      <p:grpSpPr>
+        <a:xfrm>
+          <a:off x="0" y="0"/>
+          <a:ext cx="0" cy="0"/>
+          <a:chOff x="0" y="0"/>
+          <a:chExt cx="0" cy="0"/>
+        </a:xfrm>
+      </p:grpSpPr>
+      <p:sp>
+        <p:nvSpPr>
+          <p:cNvPr id="295" name=""/>
+          <p:cNvSpPr txBox="1"/>
+          <p:nvPr/>
+        </p:nvSpPr>
+        <p:spPr>
+          <a:xfrm>
+            <a:off x="432000" y="162000"/>
+            <a:ext cx="11160000" cy="286560"/>
+          </a:xfrm>
+          <a:prstGeom prst="rect">
+            <a:avLst/>
+          </a:prstGeom>
+          <a:noFill/>
+          <a:ln w="0">
+            <a:noFill/>
+          </a:ln>
+        </p:spPr>
+        <p:txBody>
+          <a:bodyPr lIns="90000" rIns="90000" tIns="45000" bIns="45000" anchor="t">
+            <a:noAutofit/>
+          </a:bodyPr>
+          <a:p>
+            <a:pPr>
+              <a:lnSpc>
+                <a:spcPct val="115000"/>
+              </a:lnSpc>
+              <a:spcAft>
+                <a:spcPts val="482"/>
+              </a:spcAft>
+            </a:pPr>
+            <a:r>
+              <a:rPr b="1" lang="en-US" sz="1200" spc="-1" strike="noStrike">
+                <a:solidFill>
+                  <a:srgbClr val="46d4c4"/>
+                </a:solidFill>
+                <a:latin typeface="Arial"/>
+              </a:rPr>
+              <a:t>VIRTUAL BOARD / АНДРЕЙ ЮНИН / OTUS · LINUX KERNEL</a:t>
+            </a:r>
+            <a:endParaRPr b="0" lang="en-US" sz="1200" spc="-1" strike="noStrike">
+              <a:solidFill>
+                <a:srgbClr val="ffffff"/>
+              </a:solidFill>
+              <a:latin typeface="Arial"/>
+            </a:endParaRPr>
+          </a:p>
+        </p:txBody>
+      </p:sp>
+      <p:sp>
+        <p:nvSpPr>
+          <p:cNvPr id="296" name=""/>
+          <p:cNvSpPr txBox="1"/>
+          <p:nvPr/>
+        </p:nvSpPr>
+        <p:spPr>
+          <a:xfrm>
+            <a:off x="432000" y="486000"/>
+            <a:ext cx="11304000" cy="612000"/>
+          </a:xfrm>
+          <a:prstGeom prst="rect">
+            <a:avLst/>
+          </a:prstGeom>
+          <a:noFill/>
+          <a:ln w="0">
+            <a:noFill/>
+          </a:ln>
+        </p:spPr>
+        <p:txBody>
+          <a:bodyPr lIns="90000" rIns="90000" tIns="45000" bIns="45000" anchor="t">
+            <a:noAutofit/>
+          </a:bodyPr>
+          <a:p>
+            <a:pPr>
+              <a:lnSpc>
+                <a:spcPct val="115000"/>
+              </a:lnSpc>
+              <a:spcAft>
+                <a:spcPts val="482"/>
+              </a:spcAft>
+            </a:pPr>
+            <a:r>
+              <a:rPr b="1" lang="en-US" sz="3000" spc="-1" strike="noStrike">
+                <a:solidFill>
+                  <a:srgbClr val="ffffff"/>
+                </a:solidFill>
+                <a:latin typeface="Arial"/>
+              </a:rPr>
+              <a:t>Ошибка CAN: уведомить и продолжить попытки</a:t>
+            </a:r>
+            <a:endParaRPr b="0" lang="en-US" sz="3000" spc="-1" strike="noStrike">
+              <a:solidFill>
+                <a:srgbClr val="ffffff"/>
+              </a:solidFill>
+              <a:latin typeface="Arial"/>
+            </a:endParaRPr>
+          </a:p>
+        </p:txBody>
+      </p:sp>
+      <p:sp>
+        <p:nvSpPr>
+          <p:cNvPr id="297" name=""/>
+          <p:cNvSpPr txBox="1"/>
+          <p:nvPr/>
+        </p:nvSpPr>
+        <p:spPr>
+          <a:xfrm>
+            <a:off x="432000" y="6498000"/>
+            <a:ext cx="10440000" cy="349920"/>
+          </a:xfrm>
+          <a:prstGeom prst="rect">
+            <a:avLst/>
+          </a:prstGeom>
+          <a:noFill/>
+          <a:ln w="0">
+            <a:noFill/>
+          </a:ln>
+        </p:spPr>
+        <p:txBody>
+          <a:bodyPr lIns="90000" rIns="90000" tIns="45000" bIns="45000" anchor="t">
+            <a:noAutofit/>
+          </a:bodyPr>
+          <a:p>
+            <a:pPr>
+              <a:lnSpc>
+                <a:spcPct val="115000"/>
+              </a:lnSpc>
+              <a:spcAft>
+                <a:spcPts val="482"/>
+              </a:spcAft>
+            </a:pPr>
+            <a:r>
+              <a:rPr b="0" lang="en-US" sz="1600" spc="-1" strike="noStrike">
+                <a:solidFill>
+                  <a:srgbClr val="aebccd"/>
+                </a:solidFill>
+                <a:latin typeface="Arial"/>
+              </a:rPr>
+              <a:t>Источник: выводы пользователя 22.09; период передачи 1000 мс</a:t>
+            </a:r>
+            <a:endParaRPr b="0" lang="en-US" sz="1600" spc="-1" strike="noStrike">
+              <a:solidFill>
+                <a:srgbClr val="ffffff"/>
+              </a:solidFill>
+              <a:latin typeface="Arial"/>
+            </a:endParaRPr>
+          </a:p>
+        </p:txBody>
+      </p:sp>
+      <p:sp>
+        <p:nvSpPr>
+          <p:cNvPr id="298" name=""/>
+          <p:cNvSpPr txBox="1"/>
+          <p:nvPr/>
+        </p:nvSpPr>
+        <p:spPr>
+          <a:xfrm>
+            <a:off x="11160000" y="6498000"/>
+            <a:ext cx="540000" cy="349920"/>
+          </a:xfrm>
+          <a:prstGeom prst="rect">
+            <a:avLst/>
+          </a:prstGeom>
+          <a:noFill/>
+          <a:ln w="0">
+            <a:noFill/>
+          </a:ln>
+        </p:spPr>
+        <p:txBody>
+          <a:bodyPr lIns="90000" rIns="90000" tIns="45000" bIns="45000" anchor="t">
+            <a:noAutofit/>
+          </a:bodyPr>
+          <a:p>
+            <a:pPr>
+              <a:lnSpc>
+                <a:spcPct val="115000"/>
+              </a:lnSpc>
+              <a:spcAft>
+                <a:spcPts val="482"/>
+              </a:spcAft>
+            </a:pPr>
+            <a:r>
+              <a:rPr b="0" lang="en-US" sz="1600" spc="-1" strike="noStrike">
+                <a:solidFill>
+                  <a:srgbClr val="aebccd"/>
+                </a:solidFill>
+                <a:latin typeface="Arial"/>
+              </a:rPr>
+              <a:t>16</a:t>
+            </a:r>
+            <a:endParaRPr b="0" lang="en-US" sz="1600" spc="-1" strike="noStrike">
+              <a:solidFill>
+                <a:srgbClr val="ffffff"/>
+              </a:solidFill>
+              <a:latin typeface="Arial"/>
+            </a:endParaRPr>
+          </a:p>
+        </p:txBody>
+      </p:sp>
+      <p:sp>
+        <p:nvSpPr>
+          <p:cNvPr id="299" name=""/>
+          <p:cNvSpPr/>
+          <p:nvPr/>
+        </p:nvSpPr>
+        <p:spPr>
+          <a:xfrm>
+            <a:off x="432000" y="1332000"/>
+            <a:ext cx="11304000" cy="1584000"/>
+          </a:xfrm>
+          <a:prstGeom prst="rect">
+            <a:avLst/>
+          </a:prstGeom>
+          <a:solidFill>
+            <a:srgbClr val="173e43"/>
+          </a:solidFill>
+          <a:ln w="0">
+            <a:noFill/>
+          </a:ln>
+        </p:spPr>
+        <p:txBody>
+          <a:bodyPr lIns="90000" rIns="90000" tIns="45000" bIns="45000" anchor="t">
+            <a:noAutofit/>
+          </a:bodyPr>
+          <a:p>
+            <a:endParaRPr b="0" lang="en-US" sz="1800" spc="-1" strike="noStrike">
+              <a:solidFill>
+                <a:srgbClr val="ffffff"/>
+              </a:solidFill>
+              <a:latin typeface="Arial"/>
+            </a:endParaRPr>
+          </a:p>
+        </p:txBody>
+      </p:sp>
+      <p:sp>
+        <p:nvSpPr>
+          <p:cNvPr id="300" name=""/>
+          <p:cNvSpPr txBox="1"/>
+          <p:nvPr/>
+        </p:nvSpPr>
+        <p:spPr>
+          <a:xfrm>
+            <a:off x="576000" y="1440000"/>
+            <a:ext cx="11016000" cy="368640"/>
+          </a:xfrm>
+          <a:prstGeom prst="rect">
+            <a:avLst/>
+          </a:prstGeom>
+          <a:noFill/>
+          <a:ln w="0">
+            <a:noFill/>
+          </a:ln>
+        </p:spPr>
+        <p:txBody>
+          <a:bodyPr lIns="90000" rIns="90000" tIns="45000" bIns="45000" anchor="t">
+            <a:noAutofit/>
+          </a:bodyPr>
+          <a:p>
+            <a:pPr>
+              <a:lnSpc>
+                <a:spcPct val="115000"/>
+              </a:lnSpc>
+              <a:spcAft>
+                <a:spcPts val="482"/>
+              </a:spcAft>
+            </a:pPr>
+            <a:r>
+              <a:rPr b="1" lang="en-US" sz="1700" spc="-1" strike="noStrike">
+                <a:solidFill>
+                  <a:srgbClr val="46d4c4"/>
+                </a:solidFill>
+                <a:latin typeface="Arial"/>
+              </a:rPr>
+              <a:t>down → ОШИБКА; up → ВОЗОБНОВЛЕНИЕ БЕЗ start</a:t>
+            </a:r>
+            <a:endParaRPr b="0" lang="en-US" sz="1700" spc="-1" strike="noStrike">
+              <a:solidFill>
+                <a:srgbClr val="ffffff"/>
+              </a:solidFill>
+              <a:latin typeface="Arial"/>
+            </a:endParaRPr>
+          </a:p>
+        </p:txBody>
+      </p:sp>
+      <p:sp>
+        <p:nvSpPr>
+          <p:cNvPr id="301" name=""/>
+          <p:cNvSpPr txBox="1"/>
+          <p:nvPr/>
+        </p:nvSpPr>
+        <p:spPr>
+          <a:xfrm>
+            <a:off x="576000" y="1782000"/>
+            <a:ext cx="11016000" cy="1080000"/>
+          </a:xfrm>
+          <a:prstGeom prst="rect">
+            <a:avLst/>
+          </a:prstGeom>
+          <a:noFill/>
+          <a:ln w="0">
+            <a:noFill/>
+          </a:ln>
+        </p:spPr>
+        <p:txBody>
+          <a:bodyPr lIns="90000" rIns="90000" tIns="45000" bIns="45000" anchor="t">
+            <a:noAutofit/>
+          </a:bodyPr>
+          <a:p>
+            <a:endParaRPr b="0" lang="en-US" sz="1800" spc="-1" strike="noStrike">
+              <a:solidFill>
+                <a:srgbClr val="ffffff"/>
+              </a:solidFill>
+              <a:latin typeface="Arial"/>
+            </a:endParaRPr>
+          </a:p>
+        </p:txBody>
+      </p:sp>
+      <p:sp>
+        <p:nvSpPr>
+          <p:cNvPr id="302" name=""/>
+          <p:cNvSpPr txBox="1"/>
+          <p:nvPr/>
+        </p:nvSpPr>
+        <p:spPr>
+          <a:xfrm>
+            <a:off x="648000" y="1800000"/>
+            <a:ext cx="10800000" cy="813240"/>
+          </a:xfrm>
+          <a:prstGeom prst="rect">
+            <a:avLst/>
+          </a:prstGeom>
+          <a:noFill/>
+          <a:ln w="0">
+            <a:noFill/>
+          </a:ln>
+        </p:spPr>
+        <p:txBody>
+          <a:bodyPr lIns="90000" rIns="90000" tIns="45000" bIns="45000" anchor="t">
+            <a:noAutofit/>
+          </a:bodyPr>
+          <a:p>
+            <a:pPr>
+              <a:lnSpc>
+                <a:spcPct val="115000"/>
+              </a:lnSpc>
+              <a:spcAft>
+                <a:spcPts val="482"/>
+              </a:spcAft>
+            </a:pPr>
+            <a:r>
+              <a:rPr b="0" lang="en-US" sz="2000" spc="-1" strike="noStrike">
+                <a:solidFill>
+                  <a:srgbClr val="e8eef5"/>
+                </a:solidFill>
+                <a:latin typeface="Courier New"/>
+              </a:rPr>
+              <a:t>Два отключения → два события can_error, error=-100</a:t>
+            </a:r>
+            <a:endParaRPr b="0" lang="en-US" sz="2000" spc="-1" strike="noStrike">
+              <a:solidFill>
+                <a:srgbClr val="ffffff"/>
+              </a:solidFill>
+              <a:latin typeface="Arial"/>
+            </a:endParaRPr>
+          </a:p>
+          <a:p>
+            <a:pPr>
+              <a:lnSpc>
+                <a:spcPct val="115000"/>
+              </a:lnSpc>
+              <a:spcAft>
+                <a:spcPts val="482"/>
+              </a:spcAft>
+            </a:pPr>
+            <a:r>
+              <a:rPr b="0" lang="en-US" sz="2000" spc="-1" strike="noStrike">
+                <a:solidFill>
+                  <a:srgbClr val="e8eef5"/>
+                </a:solidFill>
+                <a:latin typeface="Courier New"/>
+              </a:rPr>
+              <a:t>Во время down: state=running, lost_events=0</a:t>
+            </a:r>
+            <a:endParaRPr b="0" lang="en-US" sz="2000" spc="-1" strike="noStrike">
+              <a:solidFill>
+                <a:srgbClr val="ffffff"/>
+              </a:solidFill>
+              <a:latin typeface="Arial"/>
+            </a:endParaRPr>
+          </a:p>
+        </p:txBody>
+      </p:sp>
+      <p:sp>
+        <p:nvSpPr>
+          <p:cNvPr id="303" name=""/>
+          <p:cNvSpPr txBox="1"/>
+          <p:nvPr/>
+        </p:nvSpPr>
+        <p:spPr>
+          <a:xfrm>
+            <a:off x="648000" y="2592000"/>
+            <a:ext cx="10800000" cy="349920"/>
+          </a:xfrm>
+          <a:prstGeom prst="rect">
+            <a:avLst/>
+          </a:prstGeom>
+          <a:noFill/>
+          <a:ln w="0">
+            <a:noFill/>
+          </a:ln>
+        </p:spPr>
+        <p:txBody>
+          <a:bodyPr lIns="90000" rIns="90000" tIns="45000" bIns="45000" anchor="t">
+            <a:noAutofit/>
+          </a:bodyPr>
+          <a:p>
+            <a:pPr>
+              <a:lnSpc>
+                <a:spcPct val="115000"/>
+              </a:lnSpc>
+              <a:spcAft>
+                <a:spcPts val="482"/>
+              </a:spcAft>
+            </a:pPr>
+            <a:r>
+              <a:rPr b="0" lang="en-US" sz="1600" spc="-1" strike="noStrike">
+                <a:solidFill>
+                  <a:srgbClr val="aebccd"/>
+                </a:solidFill>
+                <a:latin typeface="Arial"/>
+              </a:rPr>
+              <a:t>Успех сбрасывает прошлую ошибку; повтор одного кода не заполняет FIFO.</a:t>
+            </a:r>
+            <a:endParaRPr b="0" lang="en-US" sz="1600" spc="-1" strike="noStrike">
+              <a:solidFill>
+                <a:srgbClr val="ffffff"/>
+              </a:solidFill>
+              <a:latin typeface="Arial"/>
+            </a:endParaRPr>
+          </a:p>
+        </p:txBody>
+      </p:sp>
+      <p:sp>
+        <p:nvSpPr>
+          <p:cNvPr id="304" name=""/>
+          <p:cNvSpPr/>
+          <p:nvPr/>
+        </p:nvSpPr>
+        <p:spPr>
+          <a:xfrm>
+            <a:off x="432000" y="3204000"/>
+            <a:ext cx="5436000" cy="2160000"/>
+          </a:xfrm>
+          <a:prstGeom prst="rect">
+            <a:avLst/>
+          </a:prstGeom>
+          <a:solidFill>
+            <a:srgbClr val="203248"/>
+          </a:solidFill>
+          <a:ln w="0">
+            <a:noFill/>
+          </a:ln>
+        </p:spPr>
+        <p:txBody>
+          <a:bodyPr lIns="90000" rIns="90000" tIns="45000" bIns="45000" anchor="t">
+            <a:noAutofit/>
+          </a:bodyPr>
+          <a:p>
+            <a:endParaRPr b="0" lang="en-US" sz="1800" spc="-1" strike="noStrike">
+              <a:solidFill>
+                <a:srgbClr val="ffffff"/>
+              </a:solidFill>
+              <a:latin typeface="Arial"/>
+            </a:endParaRPr>
+          </a:p>
+        </p:txBody>
+      </p:sp>
+      <p:sp>
+        <p:nvSpPr>
+          <p:cNvPr id="305" name=""/>
+          <p:cNvSpPr txBox="1"/>
+          <p:nvPr/>
+        </p:nvSpPr>
+        <p:spPr>
+          <a:xfrm>
+            <a:off x="576000" y="3312000"/>
+            <a:ext cx="5148000" cy="368640"/>
+          </a:xfrm>
+          <a:prstGeom prst="rect">
+            <a:avLst/>
+          </a:prstGeom>
+          <a:noFill/>
+          <a:ln w="0">
+            <a:noFill/>
+          </a:ln>
+        </p:spPr>
+        <p:txBody>
+          <a:bodyPr lIns="90000" rIns="90000" tIns="45000" bIns="45000" anchor="t">
+            <a:noAutofit/>
+          </a:bodyPr>
+          <a:p>
+            <a:pPr>
+              <a:lnSpc>
+                <a:spcPct val="115000"/>
+              </a:lnSpc>
+              <a:spcAft>
+                <a:spcPts val="482"/>
+              </a:spcAft>
+            </a:pPr>
+            <a:r>
+              <a:rPr b="1" lang="en-US" sz="1700" spc="-1" strike="noStrike">
+                <a:solidFill>
+                  <a:srgbClr val="46d4c4"/>
+                </a:solidFill>
+                <a:latin typeface="Arial"/>
+              </a:rPr>
+              <a:t>ЛОКАЛЬНЫЕ СОБЫТИЯ</a:t>
+            </a:r>
+            <a:endParaRPr b="0" lang="en-US" sz="1700" spc="-1" strike="noStrike">
+              <a:solidFill>
+                <a:srgbClr val="ffffff"/>
+              </a:solidFill>
+              <a:latin typeface="Arial"/>
+            </a:endParaRPr>
+          </a:p>
+        </p:txBody>
+      </p:sp>
+      <p:sp>
+        <p:nvSpPr>
+          <p:cNvPr id="306" name=""/>
+          <p:cNvSpPr txBox="1"/>
+          <p:nvPr/>
+        </p:nvSpPr>
+        <p:spPr>
+          <a:xfrm>
+            <a:off x="576000" y="3654000"/>
+            <a:ext cx="5148000" cy="1656000"/>
+          </a:xfrm>
+          <a:prstGeom prst="rect">
+            <a:avLst/>
+          </a:prstGeom>
+          <a:noFill/>
+          <a:ln w="0">
+            <a:noFill/>
+          </a:ln>
+        </p:spPr>
+        <p:txBody>
+          <a:bodyPr lIns="90000" rIns="90000" tIns="45000" bIns="45000" anchor="t">
+            <a:noAutofit/>
+          </a:bodyPr>
+          <a:p>
+            <a:pPr>
+              <a:lnSpc>
+                <a:spcPct val="115000"/>
+              </a:lnSpc>
+              <a:spcAft>
+                <a:spcPts val="482"/>
+              </a:spcAft>
+            </a:pPr>
+            <a:r>
+              <a:rPr b="0" lang="en-US" sz="1600" spc="-1" strike="noStrike">
+                <a:solidFill>
+                  <a:srgbClr val="e8eef5"/>
+                </a:solidFill>
+                <a:latin typeface="Courier New"/>
+              </a:rPr>
+              <a:t>started</a:t>
+            </a:r>
+            <a:endParaRPr b="0" lang="en-US" sz="1600" spc="-1" strike="noStrike">
+              <a:solidFill>
+                <a:srgbClr val="ffffff"/>
+              </a:solidFill>
+              <a:latin typeface="Arial"/>
+            </a:endParaRPr>
+          </a:p>
+          <a:p>
+            <a:pPr>
+              <a:lnSpc>
+                <a:spcPct val="115000"/>
+              </a:lnSpc>
+              <a:spcAft>
+                <a:spcPts val="482"/>
+              </a:spcAft>
+            </a:pPr>
+            <a:r>
+              <a:rPr b="0" lang="en-US" sz="1600" spc="-1" strike="noStrike">
+                <a:solidFill>
+                  <a:srgbClr val="e8eef5"/>
+                </a:solidFill>
+                <a:latin typeface="Courier New"/>
+              </a:rPr>
+              <a:t>can_error: первый down</a:t>
+            </a:r>
+            <a:endParaRPr b="0" lang="en-US" sz="1600" spc="-1" strike="noStrike">
+              <a:solidFill>
+                <a:srgbClr val="ffffff"/>
+              </a:solidFill>
+              <a:latin typeface="Arial"/>
+            </a:endParaRPr>
+          </a:p>
+          <a:p>
+            <a:pPr>
+              <a:lnSpc>
+                <a:spcPct val="115000"/>
+              </a:lnSpc>
+              <a:spcAft>
+                <a:spcPts val="482"/>
+              </a:spcAft>
+            </a:pPr>
+            <a:r>
+              <a:rPr b="0" lang="en-US" sz="1600" spc="-1" strike="noStrike">
+                <a:solidFill>
+                  <a:srgbClr val="e8eef5"/>
+                </a:solidFill>
+                <a:latin typeface="Courier New"/>
+              </a:rPr>
+              <a:t>can_error: второй down</a:t>
+            </a:r>
+            <a:endParaRPr b="0" lang="en-US" sz="1600" spc="-1" strike="noStrike">
+              <a:solidFill>
+                <a:srgbClr val="ffffff"/>
+              </a:solidFill>
+              <a:latin typeface="Arial"/>
+            </a:endParaRPr>
+          </a:p>
+          <a:p>
+            <a:pPr>
+              <a:lnSpc>
+                <a:spcPct val="115000"/>
+              </a:lnSpc>
+              <a:spcAft>
+                <a:spcPts val="482"/>
+              </a:spcAft>
+            </a:pPr>
+            <a:r>
+              <a:rPr b="0" lang="en-US" sz="1600" spc="-1" strike="noStrike">
+                <a:solidFill>
+                  <a:srgbClr val="e8eef5"/>
+                </a:solidFill>
+                <a:latin typeface="Courier New"/>
+              </a:rPr>
+              <a:t>stopped</a:t>
+            </a:r>
+            <a:endParaRPr b="0" lang="en-US" sz="1600" spc="-1" strike="noStrike">
+              <a:solidFill>
+                <a:srgbClr val="ffffff"/>
+              </a:solidFill>
+              <a:latin typeface="Arial"/>
+            </a:endParaRPr>
+          </a:p>
+        </p:txBody>
+      </p:sp>
+      <p:sp>
+        <p:nvSpPr>
+          <p:cNvPr id="307" name=""/>
+          <p:cNvSpPr/>
+          <p:nvPr/>
+        </p:nvSpPr>
+        <p:spPr>
+          <a:xfrm>
+            <a:off x="6156000" y="3204000"/>
+            <a:ext cx="5580000" cy="2160000"/>
+          </a:xfrm>
+          <a:prstGeom prst="rect">
+            <a:avLst/>
+          </a:prstGeom>
+          <a:solidFill>
+            <a:srgbClr val="203248"/>
+          </a:solidFill>
+          <a:ln w="0">
+            <a:noFill/>
+          </a:ln>
+        </p:spPr>
+        <p:txBody>
+          <a:bodyPr lIns="90000" rIns="90000" tIns="45000" bIns="45000" anchor="t">
+            <a:noAutofit/>
+          </a:bodyPr>
+          <a:p>
+            <a:endParaRPr b="0" lang="en-US" sz="1800" spc="-1" strike="noStrike">
+              <a:solidFill>
+                <a:srgbClr val="ffffff"/>
+              </a:solidFill>
+              <a:latin typeface="Arial"/>
+            </a:endParaRPr>
+          </a:p>
+        </p:txBody>
+      </p:sp>
+      <p:sp>
+        <p:nvSpPr>
+          <p:cNvPr id="308" name=""/>
+          <p:cNvSpPr txBox="1"/>
+          <p:nvPr/>
+        </p:nvSpPr>
+        <p:spPr>
+          <a:xfrm>
+            <a:off x="6300000" y="3312000"/>
+            <a:ext cx="5292000" cy="368640"/>
+          </a:xfrm>
+          <a:prstGeom prst="rect">
+            <a:avLst/>
+          </a:prstGeom>
+          <a:noFill/>
+          <a:ln w="0">
+            <a:noFill/>
+          </a:ln>
+        </p:spPr>
+        <p:txBody>
+          <a:bodyPr lIns="90000" rIns="90000" tIns="45000" bIns="45000" anchor="t">
+            <a:noAutofit/>
+          </a:bodyPr>
+          <a:p>
+            <a:pPr>
+              <a:lnSpc>
+                <a:spcPct val="115000"/>
+              </a:lnSpc>
+              <a:spcAft>
+                <a:spcPts val="482"/>
+              </a:spcAft>
+            </a:pPr>
+            <a:r>
+              <a:rPr b="1" lang="en-US" sz="1700" spc="-1" strike="noStrike">
+                <a:solidFill>
+                  <a:srgbClr val="46d4c4"/>
+                </a:solidFill>
+                <a:latin typeface="Arial"/>
+              </a:rPr>
+              <a:t>НАБЛЮДЕНИЕ CAN</a:t>
+            </a:r>
+            <a:endParaRPr b="0" lang="en-US" sz="1700" spc="-1" strike="noStrike">
+              <a:solidFill>
+                <a:srgbClr val="ffffff"/>
+              </a:solidFill>
+              <a:latin typeface="Arial"/>
+            </a:endParaRPr>
+          </a:p>
+        </p:txBody>
+      </p:sp>
+      <p:sp>
+        <p:nvSpPr>
+          <p:cNvPr id="309" name=""/>
+          <p:cNvSpPr txBox="1"/>
+          <p:nvPr/>
+        </p:nvSpPr>
+        <p:spPr>
+          <a:xfrm>
+            <a:off x="6300000" y="3654000"/>
+            <a:ext cx="5292000" cy="1656000"/>
+          </a:xfrm>
+          <a:prstGeom prst="rect">
+            <a:avLst/>
+          </a:prstGeom>
+          <a:noFill/>
+          <a:ln w="0">
+            <a:noFill/>
+          </a:ln>
+        </p:spPr>
+        <p:txBody>
+          <a:bodyPr lIns="90000" rIns="90000" tIns="45000" bIns="45000" anchor="t">
+            <a:noAutofit/>
+          </a:bodyPr>
+          <a:p>
+            <a:pPr>
+              <a:lnSpc>
+                <a:spcPct val="115000"/>
+              </a:lnSpc>
+              <a:spcAft>
+                <a:spcPts val="482"/>
+              </a:spcAft>
+            </a:pPr>
+            <a:r>
+              <a:rPr b="0" lang="en-US" sz="2100" spc="-1" strike="noStrike">
+                <a:solidFill>
+                  <a:srgbClr val="e8eef5"/>
+                </a:solidFill>
+                <a:latin typeface="Arial"/>
+              </a:rPr>
+              <a:t>До down: кадры раз в секунду</a:t>
+            </a:r>
+            <a:endParaRPr b="0" lang="en-US" sz="2100" spc="-1" strike="noStrike">
+              <a:solidFill>
+                <a:srgbClr val="ffffff"/>
+              </a:solidFill>
+              <a:latin typeface="Arial"/>
+            </a:endParaRPr>
+          </a:p>
+          <a:p>
+            <a:pPr>
+              <a:lnSpc>
+                <a:spcPct val="115000"/>
+              </a:lnSpc>
+              <a:spcAft>
+                <a:spcPts val="482"/>
+              </a:spcAft>
+            </a:pPr>
+            <a:r>
+              <a:rPr b="0" lang="en-US" sz="2100" spc="-1" strike="noStrike">
+                <a:solidFill>
+                  <a:srgbClr val="e8eef5"/>
+                </a:solidFill>
+                <a:latin typeface="Arial"/>
+              </a:rPr>
+              <a:t>candump: Network is down</a:t>
+            </a:r>
+            <a:endParaRPr b="0" lang="en-US" sz="2100" spc="-1" strike="noStrike">
+              <a:solidFill>
+                <a:srgbClr val="ffffff"/>
+              </a:solidFill>
+              <a:latin typeface="Arial"/>
+            </a:endParaRPr>
+          </a:p>
+          <a:p>
+            <a:pPr>
+              <a:lnSpc>
+                <a:spcPct val="115000"/>
+              </a:lnSpc>
+              <a:spcAft>
+                <a:spcPts val="482"/>
+              </a:spcAft>
+            </a:pPr>
+            <a:r>
+              <a:rPr b="0" lang="en-US" sz="2100" spc="-1" strike="noStrike">
+                <a:solidFill>
+                  <a:srgbClr val="e8eef5"/>
+                </a:solidFill>
+                <a:latin typeface="Arial"/>
+              </a:rPr>
+              <a:t>После up: кадры возобновились</a:t>
+            </a:r>
+            <a:endParaRPr b="0" lang="en-US" sz="2100" spc="-1" strike="noStrike">
+              <a:solidFill>
+                <a:srgbClr val="ffffff"/>
+              </a:solidFill>
+              <a:latin typeface="Arial"/>
+            </a:endParaRPr>
+          </a:p>
+          <a:p>
+            <a:pPr>
+              <a:lnSpc>
+                <a:spcPct val="115000"/>
+              </a:lnSpc>
+              <a:spcAft>
+                <a:spcPts val="482"/>
+              </a:spcAft>
+            </a:pPr>
+            <a:r>
+              <a:rPr b="0" lang="en-US" sz="2100" spc="-1" strike="noStrike">
+                <a:solidFill>
+                  <a:srgbClr val="e8eef5"/>
+                </a:solidFill>
+                <a:latin typeface="Arial"/>
+              </a:rPr>
+              <a:t>Повторно запущен только candump</a:t>
+            </a:r>
+            <a:endParaRPr b="0" lang="en-US" sz="2100" spc="-1" strike="noStrike">
+              <a:solidFill>
+                <a:srgbClr val="ffffff"/>
+              </a:solidFill>
+              <a:latin typeface="Arial"/>
+            </a:endParaRPr>
+          </a:p>
+        </p:txBody>
+      </p:sp>
+      <p:sp>
+        <p:nvSpPr>
+          <p:cNvPr id="310" name=""/>
+          <p:cNvSpPr txBox="1"/>
+          <p:nvPr/>
+        </p:nvSpPr>
+        <p:spPr>
+          <a:xfrm>
+            <a:off x="432000" y="5634000"/>
+            <a:ext cx="11160000" cy="708120"/>
+          </a:xfrm>
+          <a:prstGeom prst="rect">
+            <a:avLst/>
+          </a:prstGeom>
+          <a:noFill/>
+          <a:ln w="0">
+            <a:noFill/>
+          </a:ln>
+        </p:spPr>
+        <p:txBody>
+          <a:bodyPr lIns="90000" rIns="90000" tIns="45000" bIns="45000" anchor="t">
+            <a:noAutofit/>
+          </a:bodyPr>
+          <a:p>
+            <a:pPr>
+              <a:lnSpc>
+                <a:spcPct val="115000"/>
+              </a:lnSpc>
+              <a:spcAft>
+                <a:spcPts val="482"/>
+              </a:spcAft>
+            </a:pPr>
+            <a:r>
+              <a:rPr b="0" lang="en-US" sz="1700" spc="-1" strike="noStrike">
+                <a:solidFill>
+                  <a:srgbClr val="ffd080"/>
+                </a:solidFill>
+                <a:latin typeface="Arial"/>
+              </a:rPr>
+              <a:t>running означает разрешение передачи, а не гарантию доставки.</a:t>
+            </a:r>
+            <a:endParaRPr b="0" lang="en-US" sz="1700" spc="-1" strike="noStrike">
+              <a:solidFill>
+                <a:srgbClr val="ffffff"/>
+              </a:solidFill>
+              <a:latin typeface="Arial"/>
+            </a:endParaRPr>
+          </a:p>
+          <a:p>
+            <a:pPr>
+              <a:lnSpc>
+                <a:spcPct val="115000"/>
+              </a:lnSpc>
+              <a:spcAft>
+                <a:spcPts val="482"/>
+              </a:spcAft>
+            </a:pPr>
+            <a:r>
+              <a:rPr b="0" lang="en-US" sz="1700" spc="-1" strike="noStrike">
+                <a:solidFill>
+                  <a:srgbClr val="ffd080"/>
+                </a:solidFill>
+                <a:latin typeface="Arial"/>
+              </a:rPr>
+              <a:t>Удаление интерфейса и остальные коды ошибок ещё не проверены.</a:t>
+            </a:r>
+            <a:endParaRPr b="0" lang="en-US" sz="1700" spc="-1" strike="noStrike">
+              <a:solidFill>
+                <a:srgbClr val="ffffff"/>
+              </a:solidFill>
+              <a:latin typeface="Arial"/>
+            </a:endParaRPr>
+          </a:p>
+        </p:txBody>
+      </p:sp>
+    </p:spTree>
+  </p:cSld>
+  <mc:AlternateContent>
+    <mc:Choice Requires="p14">
+      <p:transition spd="slow" p14:dur="2000"/>
+    </mc:Choice>
+    <mc:Fallback>
+      <p:transition spd="slow"/>
+    </mc:Fallback>
+  </mc:AlternateContent>
+</p:sld>
+</file>
+
 <file path=ppt/slides/slide2.xml><?xml version="1.0" encoding="utf-8"?>
 <p:sld xmlns:a="http://schemas.openxmlformats.org/drawingml/2006/main" xmlns:p="http://schemas.openxmlformats.org/presentationml/2006/main" xmlns:r="http://schemas.openxmlformats.org/officeDocument/2006/relationships" xmlns:p14="http://schemas.microsoft.com/office/powerpoint/2010/main" xmlns:p15="http://schemas.microsoft.com/office/powerpoint/2012/main" xmlns:mc="http://schemas.openxmlformats.org/markup-compatibility/2006">
   <p:cSld>
@@ -7380,7 +10308,7 @@
                 </a:solidFill>
                 <a:latin typeface="Arial"/>
               </a:rPr>
-              <a:t>22.09: обычные ioctl и события двум читателям подтверждены</a:t>
+              <a:t>write / ioctl меняют состояние; read и sysfs показывают разные данные</a:t>
             </a:r>
             <a:endParaRPr b="0" lang="en-US" sz="1600" spc="-1" strike="noStrike">
               <a:solidFill>
@@ -7800,7 +10728,7 @@
                 </a:solidFill>
                 <a:latin typeface="Arial"/>
               </a:rPr>
-              <a:t>sysfs / proc: только наблюдение</a:t>
+              <a:t>sysfs: поля; proc: сводка клиентов</a:t>
             </a:r>
             <a:endParaRPr b="0" lang="en-US" sz="1600" spc="-1" strike="noStrike">
               <a:solidFill>

</xml_diff>